<commit_message>
Updated documentation - presentation slides to highlight the completion of the AI services.
</commit_message>
<xml_diff>
--- a/docs/DocFlow Workflow.pptx
+++ b/docs/DocFlow Workflow.pptx
@@ -11,6 +11,7 @@
     <p:sldId id="257" r:id="rId5"/>
     <p:sldId id="259" r:id="rId6"/>
     <p:sldId id="258" r:id="rId7"/>
+    <p:sldId id="263" r:id="rId8"/>
   </p:sldIdLst>
   <p:sldSz cx="12192000" cy="6858000"/>
   <p:notesSz cx="6858000" cy="9144000"/>
@@ -109,6 +110,11 @@
       </a:defRPr>
     </a:lvl9pPr>
   </p:defaultTextStyle>
+  <p:extLst>
+    <p:ext uri="{EFAFB233-063F-42B5-8137-9DF3F51BA10A}">
+      <p15:sldGuideLst xmlns:p15="http://schemas.microsoft.com/office/powerpoint/2012/main"/>
+    </p:ext>
+  </p:extLst>
 </p:presentation>
 </file>
 
@@ -261,7 +267,7 @@
           <a:p>
             <a:fld id="{C6E6855C-4451-4D51-9C19-AA57B9F05DC3}" type="datetimeFigureOut">
               <a:rPr lang="en-GB" smtClean="0"/>
-              <a:t>21/05/2026</a:t>
+              <a:t>05/06/2026</a:t>
             </a:fld>
             <a:endParaRPr lang="en-GB"/>
           </a:p>
@@ -461,7 +467,7 @@
           <a:p>
             <a:fld id="{C6E6855C-4451-4D51-9C19-AA57B9F05DC3}" type="datetimeFigureOut">
               <a:rPr lang="en-GB" smtClean="0"/>
-              <a:t>21/05/2026</a:t>
+              <a:t>05/06/2026</a:t>
             </a:fld>
             <a:endParaRPr lang="en-GB"/>
           </a:p>
@@ -671,7 +677,7 @@
           <a:p>
             <a:fld id="{C6E6855C-4451-4D51-9C19-AA57B9F05DC3}" type="datetimeFigureOut">
               <a:rPr lang="en-GB" smtClean="0"/>
-              <a:t>21/05/2026</a:t>
+              <a:t>05/06/2026</a:t>
             </a:fld>
             <a:endParaRPr lang="en-GB"/>
           </a:p>
@@ -871,7 +877,7 @@
           <a:p>
             <a:fld id="{C6E6855C-4451-4D51-9C19-AA57B9F05DC3}" type="datetimeFigureOut">
               <a:rPr lang="en-GB" smtClean="0"/>
-              <a:t>21/05/2026</a:t>
+              <a:t>05/06/2026</a:t>
             </a:fld>
             <a:endParaRPr lang="en-GB"/>
           </a:p>
@@ -1147,7 +1153,7 @@
           <a:p>
             <a:fld id="{C6E6855C-4451-4D51-9C19-AA57B9F05DC3}" type="datetimeFigureOut">
               <a:rPr lang="en-GB" smtClean="0"/>
-              <a:t>21/05/2026</a:t>
+              <a:t>05/06/2026</a:t>
             </a:fld>
             <a:endParaRPr lang="en-GB"/>
           </a:p>
@@ -1415,7 +1421,7 @@
           <a:p>
             <a:fld id="{C6E6855C-4451-4D51-9C19-AA57B9F05DC3}" type="datetimeFigureOut">
               <a:rPr lang="en-GB" smtClean="0"/>
-              <a:t>21/05/2026</a:t>
+              <a:t>05/06/2026</a:t>
             </a:fld>
             <a:endParaRPr lang="en-GB"/>
           </a:p>
@@ -1830,7 +1836,7 @@
           <a:p>
             <a:fld id="{C6E6855C-4451-4D51-9C19-AA57B9F05DC3}" type="datetimeFigureOut">
               <a:rPr lang="en-GB" smtClean="0"/>
-              <a:t>21/05/2026</a:t>
+              <a:t>05/06/2026</a:t>
             </a:fld>
             <a:endParaRPr lang="en-GB"/>
           </a:p>
@@ -1972,7 +1978,7 @@
           <a:p>
             <a:fld id="{C6E6855C-4451-4D51-9C19-AA57B9F05DC3}" type="datetimeFigureOut">
               <a:rPr lang="en-GB" smtClean="0"/>
-              <a:t>21/05/2026</a:t>
+              <a:t>05/06/2026</a:t>
             </a:fld>
             <a:endParaRPr lang="en-GB"/>
           </a:p>
@@ -2085,7 +2091,7 @@
           <a:p>
             <a:fld id="{C6E6855C-4451-4D51-9C19-AA57B9F05DC3}" type="datetimeFigureOut">
               <a:rPr lang="en-GB" smtClean="0"/>
-              <a:t>21/05/2026</a:t>
+              <a:t>05/06/2026</a:t>
             </a:fld>
             <a:endParaRPr lang="en-GB"/>
           </a:p>
@@ -2398,7 +2404,7 @@
           <a:p>
             <a:fld id="{C6E6855C-4451-4D51-9C19-AA57B9F05DC3}" type="datetimeFigureOut">
               <a:rPr lang="en-GB" smtClean="0"/>
-              <a:t>21/05/2026</a:t>
+              <a:t>05/06/2026</a:t>
             </a:fld>
             <a:endParaRPr lang="en-GB"/>
           </a:p>
@@ -2687,7 +2693,7 @@
           <a:p>
             <a:fld id="{C6E6855C-4451-4D51-9C19-AA57B9F05DC3}" type="datetimeFigureOut">
               <a:rPr lang="en-GB" smtClean="0"/>
-              <a:t>21/05/2026</a:t>
+              <a:t>05/06/2026</a:t>
             </a:fld>
             <a:endParaRPr lang="en-GB"/>
           </a:p>
@@ -2930,7 +2936,7 @@
           <a:p>
             <a:fld id="{C6E6855C-4451-4D51-9C19-AA57B9F05DC3}" type="datetimeFigureOut">
               <a:rPr lang="en-GB" smtClean="0"/>
-              <a:t>21/05/2026</a:t>
+              <a:t>05/06/2026</a:t>
             </a:fld>
             <a:endParaRPr lang="en-GB"/>
           </a:p>
@@ -3465,209 +3471,6 @@
       </p:pic>
       <p:sp>
         <p:nvSpPr>
-          <p:cNvPr id="7" name="TextBox 6">
-            <a:extLst>
-              <a:ext uri="{FF2B5EF4-FFF2-40B4-BE49-F238E27FC236}">
-                <a16:creationId xmlns:a16="http://schemas.microsoft.com/office/drawing/2014/main" id="{2E295B00-63BC-9537-6B7E-9BA43607EDCC}"/>
-              </a:ext>
-            </a:extLst>
-          </p:cNvPr>
-          <p:cNvSpPr txBox="1"/>
-          <p:nvPr/>
-        </p:nvSpPr>
-        <p:spPr>
-          <a:xfrm>
-            <a:off x="2832847" y="457911"/>
-            <a:ext cx="8788452" cy="5632311"/>
-          </a:xfrm>
-          <a:prstGeom prst="rect">
-            <a:avLst/>
-          </a:prstGeom>
-          <a:noFill/>
-        </p:spPr>
-        <p:txBody>
-          <a:bodyPr wrap="square">
-            <a:spAutoFit/>
-          </a:bodyPr>
-          <a:lstStyle/>
-          <a:p>
-            <a:pPr marL="0" marR="0" lvl="0" indent="0" algn="l" defTabSz="914400" rtl="0" eaLnBrk="0" fontAlgn="base" latinLnBrk="0" hangingPunct="0">
-              <a:lnSpc>
-                <a:spcPct val="100000"/>
-              </a:lnSpc>
-              <a:spcBef>
-                <a:spcPct val="0"/>
-              </a:spcBef>
-              <a:spcAft>
-                <a:spcPct val="0"/>
-              </a:spcAft>
-              <a:buClrTx/>
-              <a:buSzTx/>
-              <a:tabLst/>
-            </a:pPr>
-            <a:r>
-              <a:rPr kumimoji="0" lang="en-US" altLang="en-US" sz="6000" b="0" i="0" u="none" strike="noStrike" cap="none" normalizeH="0" baseline="0" dirty="0">
-                <a:ln>
-                  <a:noFill/>
-                </a:ln>
-                <a:solidFill>
-                  <a:schemeClr val="tx1"/>
-                </a:solidFill>
-                <a:effectLst/>
-                <a:highlight>
-                  <a:srgbClr val="FF0000"/>
-                </a:highlight>
-                <a:latin typeface="Arial" panose="020B0604020202020204" pitchFamily="34" charset="0"/>
-              </a:rPr>
-              <a:t>Problems!</a:t>
-            </a:r>
-          </a:p>
-          <a:p>
-            <a:pPr marL="285750" marR="0" lvl="0" indent="-285750" algn="l" defTabSz="914400" rtl="0" eaLnBrk="0" fontAlgn="base" latinLnBrk="0" hangingPunct="0">
-              <a:lnSpc>
-                <a:spcPct val="100000"/>
-              </a:lnSpc>
-              <a:spcBef>
-                <a:spcPct val="0"/>
-              </a:spcBef>
-              <a:spcAft>
-                <a:spcPct val="0"/>
-              </a:spcAft>
-              <a:buClrTx/>
-              <a:buSzTx/>
-              <a:buFontTx/>
-              <a:buChar char="-"/>
-              <a:tabLst/>
-            </a:pPr>
-            <a:r>
-              <a:rPr kumimoji="0" lang="en-US" altLang="en-US" sz="6000" b="0" i="0" u="none" strike="noStrike" cap="none" normalizeH="0" baseline="0" dirty="0">
-                <a:ln>
-                  <a:noFill/>
-                </a:ln>
-                <a:solidFill>
-                  <a:schemeClr val="tx1"/>
-                </a:solidFill>
-                <a:effectLst/>
-                <a:highlight>
-                  <a:srgbClr val="FF0000"/>
-                </a:highlight>
-                <a:latin typeface="Arial" panose="020B0604020202020204" pitchFamily="34" charset="0"/>
-              </a:rPr>
-              <a:t>expensive </a:t>
-            </a:r>
-          </a:p>
-          <a:p>
-            <a:pPr marL="285750" marR="0" lvl="0" indent="-285750" algn="l" defTabSz="914400" rtl="0" eaLnBrk="0" fontAlgn="base" latinLnBrk="0" hangingPunct="0">
-              <a:lnSpc>
-                <a:spcPct val="100000"/>
-              </a:lnSpc>
-              <a:spcBef>
-                <a:spcPct val="0"/>
-              </a:spcBef>
-              <a:spcAft>
-                <a:spcPct val="0"/>
-              </a:spcAft>
-              <a:buClrTx/>
-              <a:buSzTx/>
-              <a:buFontTx/>
-              <a:buChar char="-"/>
-              <a:tabLst/>
-            </a:pPr>
-            <a:r>
-              <a:rPr kumimoji="0" lang="en-US" altLang="en-US" sz="6000" b="0" i="0" u="none" strike="noStrike" cap="none" normalizeH="0" baseline="0" dirty="0">
-                <a:ln>
-                  <a:noFill/>
-                </a:ln>
-                <a:solidFill>
-                  <a:schemeClr val="tx1"/>
-                </a:solidFill>
-                <a:effectLst/>
-                <a:highlight>
-                  <a:srgbClr val="FF0000"/>
-                </a:highlight>
-                <a:latin typeface="Arial" panose="020B0604020202020204" pitchFamily="34" charset="0"/>
-              </a:rPr>
-              <a:t>slow </a:t>
-            </a:r>
-          </a:p>
-          <a:p>
-            <a:pPr marL="285750" marR="0" lvl="0" indent="-285750" algn="l" defTabSz="914400" rtl="0" eaLnBrk="0" fontAlgn="base" latinLnBrk="0" hangingPunct="0">
-              <a:lnSpc>
-                <a:spcPct val="100000"/>
-              </a:lnSpc>
-              <a:spcBef>
-                <a:spcPct val="0"/>
-              </a:spcBef>
-              <a:spcAft>
-                <a:spcPct val="0"/>
-              </a:spcAft>
-              <a:buClrTx/>
-              <a:buSzTx/>
-              <a:buFontTx/>
-              <a:buChar char="-"/>
-              <a:tabLst/>
-            </a:pPr>
-            <a:r>
-              <a:rPr kumimoji="0" lang="en-US" altLang="en-US" sz="6000" b="0" i="0" u="none" strike="noStrike" cap="none" normalizeH="0" baseline="0" dirty="0">
-                <a:ln>
-                  <a:noFill/>
-                </a:ln>
-                <a:solidFill>
-                  <a:schemeClr val="tx1"/>
-                </a:solidFill>
-                <a:effectLst/>
-                <a:highlight>
-                  <a:srgbClr val="FF0000"/>
-                </a:highlight>
-                <a:latin typeface="Arial" panose="020B0604020202020204" pitchFamily="34" charset="0"/>
-              </a:rPr>
-              <a:t>inconsistent </a:t>
-            </a:r>
-            <a:endParaRPr lang="en-US" altLang="en-US" sz="6000" dirty="0">
-              <a:highlight>
-                <a:srgbClr val="FF0000"/>
-              </a:highlight>
-              <a:latin typeface="Arial" panose="020B0604020202020204" pitchFamily="34" charset="0"/>
-            </a:endParaRPr>
-          </a:p>
-          <a:p>
-            <a:pPr marL="285750" marR="0" lvl="0" indent="-285750" algn="l" defTabSz="914400" rtl="0" eaLnBrk="0" fontAlgn="base" latinLnBrk="0" hangingPunct="0">
-              <a:lnSpc>
-                <a:spcPct val="100000"/>
-              </a:lnSpc>
-              <a:spcBef>
-                <a:spcPct val="0"/>
-              </a:spcBef>
-              <a:spcAft>
-                <a:spcPct val="0"/>
-              </a:spcAft>
-              <a:buClrTx/>
-              <a:buSzTx/>
-              <a:buFontTx/>
-              <a:buChar char="-"/>
-              <a:tabLst/>
-            </a:pPr>
-            <a:r>
-              <a:rPr kumimoji="0" lang="en-US" altLang="en-US" sz="6000" b="0" i="0" u="none" strike="noStrike" cap="none" normalizeH="0" baseline="0" dirty="0">
-                <a:ln>
-                  <a:noFill/>
-                </a:ln>
-                <a:solidFill>
-                  <a:schemeClr val="tx1"/>
-                </a:solidFill>
-                <a:effectLst/>
-                <a:highlight>
-                  <a:srgbClr val="FF0000"/>
-                </a:highlight>
-                <a:latin typeface="Arial" panose="020B0604020202020204" pitchFamily="34" charset="0"/>
-              </a:rPr>
-              <a:t>impossible to scale efficiently </a:t>
-            </a:r>
-          </a:p>
-        </p:txBody>
-      </p:sp>
-      <p:sp>
-        <p:nvSpPr>
           <p:cNvPr id="8" name="Rectangle 7">
             <a:extLst>
               <a:ext uri="{FF2B5EF4-FFF2-40B4-BE49-F238E27FC236}">
@@ -3970,8 +3773,8 @@
         </p:nvSpPr>
         <p:spPr>
           <a:xfrm>
-            <a:off x="835090" y="1065910"/>
-            <a:ext cx="6096000" cy="1200329"/>
+            <a:off x="918883" y="516396"/>
+            <a:ext cx="6096000" cy="1477328"/>
           </a:xfrm>
           <a:prstGeom prst="rect">
             <a:avLst/>
@@ -4009,8 +3812,34 @@
                 <a:effectLst/>
                 <a:latin typeface="Arial" panose="020B0604020202020204" pitchFamily="34" charset="0"/>
               </a:rPr>
-              <a:t>Lots of documents!</a:t>
+              <a:t>Many documents!</a:t>
             </a:r>
+          </a:p>
+          <a:p>
+            <a:pPr eaLnBrk="0" fontAlgn="base" hangingPunct="0">
+              <a:spcBef>
+                <a:spcPct val="0"/>
+              </a:spcBef>
+              <a:spcAft>
+                <a:spcPct val="0"/>
+              </a:spcAft>
+            </a:pPr>
+            <a:r>
+              <a:rPr lang="en-US" altLang="en-US" dirty="0">
+                <a:latin typeface="Arial" panose="020B0604020202020204" pitchFamily="34" charset="0"/>
+              </a:rPr>
+              <a:t>Many types of documents!</a:t>
+            </a:r>
+            <a:endParaRPr kumimoji="0" lang="en-US" altLang="en-US" sz="1800" b="0" i="0" u="none" strike="noStrike" cap="none" normalizeH="0" baseline="0" dirty="0">
+              <a:ln>
+                <a:noFill/>
+              </a:ln>
+              <a:solidFill>
+                <a:schemeClr val="tx1"/>
+              </a:solidFill>
+              <a:effectLst/>
+              <a:latin typeface="Arial" panose="020B0604020202020204" pitchFamily="34" charset="0"/>
+            </a:endParaRPr>
           </a:p>
           <a:p>
             <a:pPr marL="285750" marR="0" lvl="0" indent="-285750" algn="l" defTabSz="914400" rtl="0" eaLnBrk="0" fontAlgn="base" latinLnBrk="0" hangingPunct="0">
@@ -4106,6 +3935,180 @@
               </a:solidFill>
               <a:effectLst/>
               <a:latin typeface="Arial" panose="020B0604020202020204" pitchFamily="34" charset="0"/>
+            </a:endParaRPr>
+          </a:p>
+        </p:txBody>
+      </p:sp>
+      <p:sp>
+        <p:nvSpPr>
+          <p:cNvPr id="3" name="&quot;Not Allowed&quot; Symbol 2">
+            <a:extLst>
+              <a:ext uri="{FF2B5EF4-FFF2-40B4-BE49-F238E27FC236}">
+                <a16:creationId xmlns:a16="http://schemas.microsoft.com/office/drawing/2014/main" id="{16F8347D-C880-C29E-1B2B-84893529CAD8}"/>
+              </a:ext>
+            </a:extLst>
+          </p:cNvPr>
+          <p:cNvSpPr/>
+          <p:nvPr/>
+        </p:nvSpPr>
+        <p:spPr>
+          <a:xfrm>
+            <a:off x="3408030" y="1255060"/>
+            <a:ext cx="4132730" cy="4151549"/>
+          </a:xfrm>
+          <a:prstGeom prst="noSmoking">
+            <a:avLst/>
+          </a:prstGeom>
+        </p:spPr>
+        <p:style>
+          <a:lnRef idx="2">
+            <a:schemeClr val="accent2">
+              <a:shade val="15000"/>
+            </a:schemeClr>
+          </a:lnRef>
+          <a:fillRef idx="1">
+            <a:schemeClr val="accent2"/>
+          </a:fillRef>
+          <a:effectRef idx="0">
+            <a:schemeClr val="accent2"/>
+          </a:effectRef>
+          <a:fontRef idx="minor">
+            <a:schemeClr val="lt1"/>
+          </a:fontRef>
+        </p:style>
+        <p:txBody>
+          <a:bodyPr rtlCol="0" anchor="ctr"/>
+          <a:lstStyle/>
+          <a:p>
+            <a:pPr lvl="1" eaLnBrk="0" fontAlgn="base" hangingPunct="0">
+              <a:spcBef>
+                <a:spcPct val="0"/>
+              </a:spcBef>
+              <a:spcAft>
+                <a:spcPct val="0"/>
+              </a:spcAft>
+            </a:pPr>
+            <a:r>
+              <a:rPr lang="en-US" altLang="en-US" sz="1400" dirty="0">
+                <a:solidFill>
+                  <a:schemeClr val="tx1"/>
+                </a:solidFill>
+                <a:highlight>
+                  <a:srgbClr val="FF0000"/>
+                </a:highlight>
+                <a:latin typeface="Arial" panose="020B0604020202020204" pitchFamily="34" charset="0"/>
+              </a:rPr>
+              <a:t>Problems!</a:t>
+            </a:r>
+          </a:p>
+          <a:p>
+            <a:pPr marL="742950" lvl="1" indent="-285750" eaLnBrk="0" fontAlgn="base" hangingPunct="0">
+              <a:spcBef>
+                <a:spcPct val="0"/>
+              </a:spcBef>
+              <a:spcAft>
+                <a:spcPct val="0"/>
+              </a:spcAft>
+              <a:buFontTx/>
+              <a:buChar char="-"/>
+            </a:pPr>
+            <a:r>
+              <a:rPr lang="en-US" altLang="en-US" sz="1400" dirty="0">
+                <a:solidFill>
+                  <a:schemeClr val="tx1"/>
+                </a:solidFill>
+                <a:highlight>
+                  <a:srgbClr val="FF0000"/>
+                </a:highlight>
+                <a:latin typeface="Arial" panose="020B0604020202020204" pitchFamily="34" charset="0"/>
+              </a:rPr>
+              <a:t>slow </a:t>
+            </a:r>
+          </a:p>
+          <a:p>
+            <a:pPr marL="742950" lvl="1" indent="-285750" eaLnBrk="0" fontAlgn="base" hangingPunct="0">
+              <a:spcBef>
+                <a:spcPct val="0"/>
+              </a:spcBef>
+              <a:spcAft>
+                <a:spcPct val="0"/>
+              </a:spcAft>
+              <a:buFontTx/>
+              <a:buChar char="-"/>
+            </a:pPr>
+            <a:r>
+              <a:rPr lang="en-US" altLang="en-US" sz="1400" dirty="0">
+                <a:solidFill>
+                  <a:schemeClr val="tx1"/>
+                </a:solidFill>
+                <a:highlight>
+                  <a:srgbClr val="FF0000"/>
+                </a:highlight>
+                <a:latin typeface="Arial" panose="020B0604020202020204" pitchFamily="34" charset="0"/>
+              </a:rPr>
+              <a:t>expensive </a:t>
+            </a:r>
+          </a:p>
+          <a:p>
+            <a:pPr marL="742950" lvl="1" indent="-285750" eaLnBrk="0" fontAlgn="base" hangingPunct="0">
+              <a:spcBef>
+                <a:spcPct val="0"/>
+              </a:spcBef>
+              <a:spcAft>
+                <a:spcPct val="0"/>
+              </a:spcAft>
+              <a:buFontTx/>
+              <a:buChar char="-"/>
+            </a:pPr>
+            <a:r>
+              <a:rPr lang="en-US" altLang="en-US" sz="1400" dirty="0">
+                <a:solidFill>
+                  <a:schemeClr val="tx1"/>
+                </a:solidFill>
+                <a:highlight>
+                  <a:srgbClr val="FF0000"/>
+                </a:highlight>
+                <a:latin typeface="Arial" panose="020B0604020202020204" pitchFamily="34" charset="0"/>
+              </a:rPr>
+              <a:t>inconsistent </a:t>
+            </a:r>
+            <a:endParaRPr lang="en-US" altLang="en-US" sz="1400" dirty="0">
+              <a:highlight>
+                <a:srgbClr val="FF0000"/>
+              </a:highlight>
+              <a:latin typeface="Arial" panose="020B0604020202020204" pitchFamily="34" charset="0"/>
+            </a:endParaRPr>
+          </a:p>
+          <a:p>
+            <a:pPr marL="742950" lvl="1" indent="-285750" eaLnBrk="0" fontAlgn="base" hangingPunct="0">
+              <a:spcBef>
+                <a:spcPct val="0"/>
+              </a:spcBef>
+              <a:spcAft>
+                <a:spcPct val="0"/>
+              </a:spcAft>
+              <a:buFontTx/>
+              <a:buChar char="-"/>
+            </a:pPr>
+            <a:r>
+              <a:rPr lang="en-US" altLang="en-US" sz="1400" dirty="0">
+                <a:solidFill>
+                  <a:schemeClr val="tx1"/>
+                </a:solidFill>
+                <a:highlight>
+                  <a:srgbClr val="FF0000"/>
+                </a:highlight>
+                <a:latin typeface="Arial" panose="020B0604020202020204" pitchFamily="34" charset="0"/>
+              </a:rPr>
+              <a:t>impossible to scale efficiently </a:t>
+            </a:r>
+          </a:p>
+          <a:p>
+            <a:pPr lvl="1" algn="ctr"/>
+            <a:endParaRPr lang="en-GB" sz="1400" dirty="0">
+              <a:solidFill>
+                <a:schemeClr val="tx1"/>
+              </a:solidFill>
             </a:endParaRPr>
           </a:p>
         </p:txBody>
@@ -4220,15 +4223,33 @@
                                   </p:childTnLst>
                                 </p:cTn>
                               </p:par>
+                            </p:childTnLst>
+                          </p:cTn>
+                        </p:par>
+                      </p:childTnLst>
+                    </p:cTn>
+                  </p:par>
+                  <p:par>
+                    <p:cTn id="11" fill="hold">
+                      <p:stCondLst>
+                        <p:cond delay="indefinite"/>
+                      </p:stCondLst>
+                      <p:childTnLst>
+                        <p:par>
+                          <p:cTn id="12" fill="hold">
+                            <p:stCondLst>
+                              <p:cond delay="0"/>
+                            </p:stCondLst>
+                            <p:childTnLst>
                               <p:par>
-                                <p:cTn id="11" presetID="1" presetClass="entr" presetSubtype="0" fill="hold" nodeType="withEffect">
+                                <p:cTn id="13" presetID="1" presetClass="entr" presetSubtype="0" fill="hold" nodeType="clickEffect">
                                   <p:stCondLst>
                                     <p:cond delay="0"/>
                                   </p:stCondLst>
                                   <p:childTnLst>
                                     <p:set>
                                       <p:cBhvr>
-                                        <p:cTn id="12" dur="1" fill="hold">
+                                        <p:cTn id="14" dur="1" fill="hold">
                                           <p:stCondLst>
                                             <p:cond delay="0"/>
                                           </p:stCondLst>
@@ -4252,14 +4273,14 @@
                                 </p:cTn>
                               </p:par>
                               <p:par>
-                                <p:cTn id="13" presetID="1" presetClass="entr" presetSubtype="0" fill="hold" nodeType="withEffect">
+                                <p:cTn id="15" presetID="1" presetClass="entr" presetSubtype="0" fill="hold" nodeType="withEffect">
                                   <p:stCondLst>
                                     <p:cond delay="0"/>
                                   </p:stCondLst>
                                   <p:childTnLst>
                                     <p:set>
                                       <p:cBhvr>
-                                        <p:cTn id="14" dur="1" fill="hold">
+                                        <p:cTn id="16" dur="1" fill="hold">
                                           <p:stCondLst>
                                             <p:cond delay="0"/>
                                           </p:stCondLst>
@@ -4268,6 +4289,37 @@
                                           <p:spTgt spid="17">
                                             <p:txEl>
                                               <p:pRg st="3" end="3"/>
+                                            </p:txEl>
+                                          </p:spTgt>
+                                        </p:tgtEl>
+                                        <p:attrNameLst>
+                                          <p:attrName>style.visibility</p:attrName>
+                                        </p:attrNameLst>
+                                      </p:cBhvr>
+                                      <p:to>
+                                        <p:strVal val="visible"/>
+                                      </p:to>
+                                    </p:set>
+                                  </p:childTnLst>
+                                </p:cTn>
+                              </p:par>
+                              <p:par>
+                                <p:cTn id="17" presetID="1" presetClass="entr" presetSubtype="0" fill="hold" nodeType="withEffect">
+                                  <p:stCondLst>
+                                    <p:cond delay="0"/>
+                                  </p:stCondLst>
+                                  <p:childTnLst>
+                                    <p:set>
+                                      <p:cBhvr>
+                                        <p:cTn id="18" dur="1" fill="hold">
+                                          <p:stCondLst>
+                                            <p:cond delay="0"/>
+                                          </p:stCondLst>
+                                        </p:cTn>
+                                        <p:tgtEl>
+                                          <p:spTgt spid="17">
+                                            <p:txEl>
+                                              <p:pRg st="4" end="4"/>
                                             </p:txEl>
                                           </p:spTgt>
                                         </p:tgtEl>
@@ -4289,26 +4341,26 @@
                     </p:cTn>
                   </p:par>
                   <p:par>
-                    <p:cTn id="15" fill="hold">
+                    <p:cTn id="19" fill="hold">
                       <p:stCondLst>
                         <p:cond delay="indefinite"/>
                       </p:stCondLst>
                       <p:childTnLst>
                         <p:par>
-                          <p:cTn id="16" fill="hold">
+                          <p:cTn id="20" fill="hold">
                             <p:stCondLst>
                               <p:cond delay="0"/>
                             </p:stCondLst>
                             <p:childTnLst>
                               <p:par>
-                                <p:cTn id="17" presetID="10" presetClass="exit" presetSubtype="0" fill="hold" grpId="0" nodeType="clickEffect">
+                                <p:cTn id="21" presetID="10" presetClass="exit" presetSubtype="0" fill="hold" grpId="0" nodeType="clickEffect">
                                   <p:stCondLst>
                                     <p:cond delay="0"/>
                                   </p:stCondLst>
                                   <p:childTnLst>
                                     <p:animEffect transition="out" filter="fade">
                                       <p:cBhvr>
-                                        <p:cTn id="18" dur="500"/>
+                                        <p:cTn id="22" dur="500"/>
                                         <p:tgtEl>
                                           <p:spTgt spid="17">
                                             <p:txEl>
@@ -4320,7 +4372,7 @@
                                     </p:animEffect>
                                     <p:set>
                                       <p:cBhvr>
-                                        <p:cTn id="19" dur="1" fill="hold">
+                                        <p:cTn id="23" dur="1" fill="hold">
                                           <p:stCondLst>
                                             <p:cond delay="499"/>
                                           </p:stCondLst>
@@ -4344,14 +4396,14 @@
                                 </p:cTn>
                               </p:par>
                               <p:par>
-                                <p:cTn id="20" presetID="10" presetClass="exit" presetSubtype="0" fill="hold" grpId="0" nodeType="withEffect">
+                                <p:cTn id="24" presetID="10" presetClass="exit" presetSubtype="0" fill="hold" grpId="0" nodeType="withEffect">
                                   <p:stCondLst>
                                     <p:cond delay="0"/>
                                   </p:stCondLst>
                                   <p:childTnLst>
                                     <p:animEffect transition="out" filter="fade">
                                       <p:cBhvr>
-                                        <p:cTn id="21" dur="500"/>
+                                        <p:cTn id="25" dur="500"/>
                                         <p:tgtEl>
                                           <p:spTgt spid="17">
                                             <p:txEl>
@@ -4363,7 +4415,7 @@
                                     </p:animEffect>
                                     <p:set>
                                       <p:cBhvr>
-                                        <p:cTn id="22" dur="1" fill="hold">
+                                        <p:cTn id="26" dur="1" fill="hold">
                                           <p:stCondLst>
                                             <p:cond delay="499"/>
                                           </p:stCondLst>
@@ -4387,14 +4439,14 @@
                                 </p:cTn>
                               </p:par>
                               <p:par>
-                                <p:cTn id="23" presetID="10" presetClass="exit" presetSubtype="0" fill="hold" grpId="0" nodeType="withEffect">
+                                <p:cTn id="27" presetID="10" presetClass="exit" presetSubtype="0" fill="hold" grpId="0" nodeType="withEffect">
                                   <p:stCondLst>
                                     <p:cond delay="0"/>
                                   </p:stCondLst>
                                   <p:childTnLst>
                                     <p:animEffect transition="out" filter="fade">
                                       <p:cBhvr>
-                                        <p:cTn id="24" dur="500"/>
+                                        <p:cTn id="28" dur="500"/>
                                         <p:tgtEl>
                                           <p:spTgt spid="17">
                                             <p:txEl>
@@ -4406,7 +4458,7 @@
                                     </p:animEffect>
                                     <p:set>
                                       <p:cBhvr>
-                                        <p:cTn id="25" dur="1" fill="hold">
+                                        <p:cTn id="29" dur="1" fill="hold">
                                           <p:stCondLst>
                                             <p:cond delay="499"/>
                                           </p:stCondLst>
@@ -4430,14 +4482,14 @@
                                 </p:cTn>
                               </p:par>
                               <p:par>
-                                <p:cTn id="26" presetID="10" presetClass="exit" presetSubtype="0" fill="hold" grpId="0" nodeType="withEffect">
+                                <p:cTn id="30" presetID="10" presetClass="exit" presetSubtype="0" fill="hold" grpId="0" nodeType="withEffect">
                                   <p:stCondLst>
                                     <p:cond delay="0"/>
                                   </p:stCondLst>
                                   <p:childTnLst>
                                     <p:animEffect transition="out" filter="fade">
                                       <p:cBhvr>
-                                        <p:cTn id="27" dur="500"/>
+                                        <p:cTn id="31" dur="500"/>
                                         <p:tgtEl>
                                           <p:spTgt spid="17">
                                             <p:txEl>
@@ -4449,7 +4501,7 @@
                                     </p:animEffect>
                                     <p:set>
                                       <p:cBhvr>
-                                        <p:cTn id="28" dur="1" fill="hold">
+                                        <p:cTn id="32" dur="1" fill="hold">
                                           <p:stCondLst>
                                             <p:cond delay="499"/>
                                           </p:stCondLst>
@@ -4458,6 +4510,49 @@
                                           <p:spTgt spid="17">
                                             <p:txEl>
                                               <p:pRg st="3" end="3"/>
+                                            </p:txEl>
+                                          </p:spTgt>
+                                        </p:tgtEl>
+                                        <p:attrNameLst>
+                                          <p:attrName>style.visibility</p:attrName>
+                                        </p:attrNameLst>
+                                      </p:cBhvr>
+                                      <p:to>
+                                        <p:strVal val="hidden"/>
+                                      </p:to>
+                                    </p:set>
+                                  </p:childTnLst>
+                                </p:cTn>
+                              </p:par>
+                              <p:par>
+                                <p:cTn id="33" presetID="10" presetClass="exit" presetSubtype="0" fill="hold" grpId="0" nodeType="withEffect">
+                                  <p:stCondLst>
+                                    <p:cond delay="0"/>
+                                  </p:stCondLst>
+                                  <p:childTnLst>
+                                    <p:animEffect transition="out" filter="fade">
+                                      <p:cBhvr>
+                                        <p:cTn id="34" dur="500"/>
+                                        <p:tgtEl>
+                                          <p:spTgt spid="17">
+                                            <p:txEl>
+                                              <p:pRg st="4" end="4"/>
+                                            </p:txEl>
+                                          </p:spTgt>
+                                        </p:tgtEl>
+                                      </p:cBhvr>
+                                    </p:animEffect>
+                                    <p:set>
+                                      <p:cBhvr>
+                                        <p:cTn id="35" dur="1" fill="hold">
+                                          <p:stCondLst>
+                                            <p:cond delay="499"/>
+                                          </p:stCondLst>
+                                        </p:cTn>
+                                        <p:tgtEl>
+                                          <p:spTgt spid="17">
+                                            <p:txEl>
+                                              <p:pRg st="4" end="4"/>
                                             </p:txEl>
                                           </p:spTgt>
                                         </p:tgtEl>
@@ -4479,26 +4574,26 @@
                     </p:cTn>
                   </p:par>
                   <p:par>
-                    <p:cTn id="29" fill="hold">
+                    <p:cTn id="36" fill="hold">
                       <p:stCondLst>
                         <p:cond delay="indefinite"/>
                       </p:stCondLst>
                       <p:childTnLst>
                         <p:par>
-                          <p:cTn id="30" fill="hold">
+                          <p:cTn id="37" fill="hold">
                             <p:stCondLst>
                               <p:cond delay="0"/>
                             </p:stCondLst>
                             <p:childTnLst>
                               <p:par>
-                                <p:cTn id="31" presetID="10" presetClass="entr" presetSubtype="0" fill="hold" grpId="0" nodeType="clickEffect">
+                                <p:cTn id="38" presetID="10" presetClass="entr" presetSubtype="0" fill="hold" grpId="0" nodeType="clickEffect">
                                   <p:stCondLst>
                                     <p:cond delay="0"/>
                                   </p:stCondLst>
                                   <p:childTnLst>
                                     <p:set>
                                       <p:cBhvr>
-                                        <p:cTn id="32" dur="1" fill="hold">
+                                        <p:cTn id="39" dur="1" fill="hold">
                                           <p:stCondLst>
                                             <p:cond delay="0"/>
                                           </p:stCondLst>
@@ -4516,7 +4611,7 @@
                                     </p:set>
                                     <p:animEffect transition="in" filter="fade">
                                       <p:cBhvr>
-                                        <p:cTn id="33" dur="500"/>
+                                        <p:cTn id="40" dur="500"/>
                                         <p:tgtEl>
                                           <p:spTgt spid="8"/>
                                         </p:tgtEl>
@@ -4532,26 +4627,26 @@
                     </p:cTn>
                   </p:par>
                   <p:par>
-                    <p:cTn id="34" fill="hold">
+                    <p:cTn id="41" fill="hold">
                       <p:stCondLst>
                         <p:cond delay="indefinite"/>
                       </p:stCondLst>
                       <p:childTnLst>
                         <p:par>
-                          <p:cTn id="35" fill="hold">
+                          <p:cTn id="42" fill="hold">
                             <p:stCondLst>
                               <p:cond delay="0"/>
                             </p:stCondLst>
                             <p:childTnLst>
                               <p:par>
-                                <p:cTn id="36" presetID="10" presetClass="exit" presetSubtype="0" fill="hold" grpId="1" nodeType="clickEffect">
+                                <p:cTn id="43" presetID="10" presetClass="exit" presetSubtype="0" fill="hold" grpId="1" nodeType="clickEffect">
                                   <p:stCondLst>
                                     <p:cond delay="0"/>
                                   </p:stCondLst>
                                   <p:childTnLst>
                                     <p:animEffect transition="out" filter="fade">
                                       <p:cBhvr>
-                                        <p:cTn id="37" dur="500"/>
+                                        <p:cTn id="44" dur="500"/>
                                         <p:tgtEl>
                                           <p:spTgt spid="8"/>
                                         </p:tgtEl>
@@ -4559,7 +4654,7 @@
                                     </p:animEffect>
                                     <p:set>
                                       <p:cBhvr>
-                                        <p:cTn id="38" dur="1" fill="hold">
+                                        <p:cTn id="45" dur="1" fill="hold">
                                           <p:stCondLst>
                                             <p:cond delay="499"/>
                                           </p:stCondLst>
@@ -4579,14 +4674,14 @@
                                 </p:cTn>
                               </p:par>
                               <p:par>
-                                <p:cTn id="39" presetID="10" presetClass="entr" presetSubtype="0" fill="hold" grpId="0" nodeType="withEffect">
+                                <p:cTn id="46" presetID="10" presetClass="entr" presetSubtype="0" fill="hold" grpId="0" nodeType="withEffect">
                                   <p:stCondLst>
                                     <p:cond delay="0"/>
                                   </p:stCondLst>
                                   <p:childTnLst>
                                     <p:set>
                                       <p:cBhvr>
-                                        <p:cTn id="40" dur="1" fill="hold">
+                                        <p:cTn id="47" dur="1" fill="hold">
                                           <p:stCondLst>
                                             <p:cond delay="0"/>
                                           </p:stCondLst>
@@ -4604,7 +4699,7 @@
                                     </p:set>
                                     <p:animEffect transition="in" filter="fade">
                                       <p:cBhvr>
-                                        <p:cTn id="41" dur="500"/>
+                                        <p:cTn id="48" dur="500"/>
                                         <p:tgtEl>
                                           <p:spTgt spid="11"/>
                                         </p:tgtEl>
@@ -4620,26 +4715,26 @@
                     </p:cTn>
                   </p:par>
                   <p:par>
-                    <p:cTn id="42" fill="hold">
+                    <p:cTn id="49" fill="hold">
                       <p:stCondLst>
                         <p:cond delay="indefinite"/>
                       </p:stCondLst>
                       <p:childTnLst>
                         <p:par>
-                          <p:cTn id="43" fill="hold">
+                          <p:cTn id="50" fill="hold">
                             <p:stCondLst>
                               <p:cond delay="0"/>
                             </p:stCondLst>
                             <p:childTnLst>
                               <p:par>
-                                <p:cTn id="44" presetID="10" presetClass="exit" presetSubtype="0" fill="hold" grpId="1" nodeType="clickEffect">
+                                <p:cTn id="51" presetID="10" presetClass="exit" presetSubtype="0" fill="hold" grpId="1" nodeType="clickEffect">
                                   <p:stCondLst>
                                     <p:cond delay="0"/>
                                   </p:stCondLst>
                                   <p:childTnLst>
                                     <p:animEffect transition="out" filter="fade">
                                       <p:cBhvr>
-                                        <p:cTn id="45" dur="500"/>
+                                        <p:cTn id="52" dur="500"/>
                                         <p:tgtEl>
                                           <p:spTgt spid="11"/>
                                         </p:tgtEl>
@@ -4647,7 +4742,7 @@
                                     </p:animEffect>
                                     <p:set>
                                       <p:cBhvr>
-                                        <p:cTn id="46" dur="1" fill="hold">
+                                        <p:cTn id="53" dur="1" fill="hold">
                                           <p:stCondLst>
                                             <p:cond delay="499"/>
                                           </p:stCondLst>
@@ -4667,14 +4762,14 @@
                                 </p:cTn>
                               </p:par>
                               <p:par>
-                                <p:cTn id="47" presetID="10" presetClass="entr" presetSubtype="0" fill="hold" grpId="0" nodeType="withEffect">
+                                <p:cTn id="54" presetID="10" presetClass="entr" presetSubtype="0" fill="hold" grpId="0" nodeType="withEffect">
                                   <p:stCondLst>
                                     <p:cond delay="0"/>
                                   </p:stCondLst>
                                   <p:childTnLst>
                                     <p:set>
                                       <p:cBhvr>
-                                        <p:cTn id="48" dur="1" fill="hold">
+                                        <p:cTn id="55" dur="1" fill="hold">
                                           <p:stCondLst>
                                             <p:cond delay="0"/>
                                           </p:stCondLst>
@@ -4692,7 +4787,7 @@
                                     </p:set>
                                     <p:animEffect transition="in" filter="fade">
                                       <p:cBhvr>
-                                        <p:cTn id="49" dur="500"/>
+                                        <p:cTn id="56" dur="500"/>
                                         <p:tgtEl>
                                           <p:spTgt spid="12"/>
                                         </p:tgtEl>
@@ -4708,26 +4803,26 @@
                     </p:cTn>
                   </p:par>
                   <p:par>
-                    <p:cTn id="50" fill="hold">
+                    <p:cTn id="57" fill="hold">
                       <p:stCondLst>
                         <p:cond delay="indefinite"/>
                       </p:stCondLst>
                       <p:childTnLst>
                         <p:par>
-                          <p:cTn id="51" fill="hold">
+                          <p:cTn id="58" fill="hold">
                             <p:stCondLst>
                               <p:cond delay="0"/>
                             </p:stCondLst>
                             <p:childTnLst>
                               <p:par>
-                                <p:cTn id="52" presetID="10" presetClass="exit" presetSubtype="0" fill="hold" grpId="1" nodeType="clickEffect">
+                                <p:cTn id="59" presetID="10" presetClass="exit" presetSubtype="0" fill="hold" grpId="1" nodeType="clickEffect">
                                   <p:stCondLst>
                                     <p:cond delay="0"/>
                                   </p:stCondLst>
                                   <p:childTnLst>
                                     <p:animEffect transition="out" filter="fade">
                                       <p:cBhvr>
-                                        <p:cTn id="53" dur="500"/>
+                                        <p:cTn id="60" dur="500"/>
                                         <p:tgtEl>
                                           <p:spTgt spid="12"/>
                                         </p:tgtEl>
@@ -4735,7 +4830,7 @@
                                     </p:animEffect>
                                     <p:set>
                                       <p:cBhvr>
-                                        <p:cTn id="54" dur="1" fill="hold">
+                                        <p:cTn id="61" dur="1" fill="hold">
                                           <p:stCondLst>
                                             <p:cond delay="499"/>
                                           </p:stCondLst>
@@ -4755,14 +4850,14 @@
                                 </p:cTn>
                               </p:par>
                               <p:par>
-                                <p:cTn id="55" presetID="10" presetClass="entr" presetSubtype="0" fill="hold" grpId="0" nodeType="withEffect">
+                                <p:cTn id="62" presetID="10" presetClass="entr" presetSubtype="0" fill="hold" grpId="0" nodeType="withEffect">
                                   <p:stCondLst>
                                     <p:cond delay="0"/>
                                   </p:stCondLst>
                                   <p:childTnLst>
                                     <p:set>
                                       <p:cBhvr>
-                                        <p:cTn id="56" dur="1" fill="hold">
+                                        <p:cTn id="63" dur="1" fill="hold">
                                           <p:stCondLst>
                                             <p:cond delay="0"/>
                                           </p:stCondLst>
@@ -4780,7 +4875,7 @@
                                     </p:set>
                                     <p:animEffect transition="in" filter="fade">
                                       <p:cBhvr>
-                                        <p:cTn id="57" dur="500"/>
+                                        <p:cTn id="64" dur="500"/>
                                         <p:tgtEl>
                                           <p:spTgt spid="13"/>
                                         </p:tgtEl>
@@ -4796,26 +4891,26 @@
                     </p:cTn>
                   </p:par>
                   <p:par>
-                    <p:cTn id="58" fill="hold">
+                    <p:cTn id="65" fill="hold">
                       <p:stCondLst>
                         <p:cond delay="indefinite"/>
                       </p:stCondLst>
                       <p:childTnLst>
                         <p:par>
-                          <p:cTn id="59" fill="hold">
+                          <p:cTn id="66" fill="hold">
                             <p:stCondLst>
                               <p:cond delay="0"/>
                             </p:stCondLst>
                             <p:childTnLst>
                               <p:par>
-                                <p:cTn id="60" presetID="10" presetClass="exit" presetSubtype="0" fill="hold" grpId="1" nodeType="clickEffect">
+                                <p:cTn id="67" presetID="10" presetClass="exit" presetSubtype="0" fill="hold" grpId="1" nodeType="clickEffect">
                                   <p:stCondLst>
                                     <p:cond delay="0"/>
                                   </p:stCondLst>
                                   <p:childTnLst>
                                     <p:animEffect transition="out" filter="fade">
                                       <p:cBhvr>
-                                        <p:cTn id="61" dur="500"/>
+                                        <p:cTn id="68" dur="500"/>
                                         <p:tgtEl>
                                           <p:spTgt spid="13"/>
                                         </p:tgtEl>
@@ -4823,7 +4918,7 @@
                                     </p:animEffect>
                                     <p:set>
                                       <p:cBhvr>
-                                        <p:cTn id="62" dur="1" fill="hold">
+                                        <p:cTn id="69" dur="1" fill="hold">
                                           <p:stCondLst>
                                             <p:cond delay="499"/>
                                           </p:stCondLst>
@@ -4843,14 +4938,14 @@
                                 </p:cTn>
                               </p:par>
                               <p:par>
-                                <p:cTn id="63" presetID="10" presetClass="entr" presetSubtype="0" fill="hold" grpId="0" nodeType="withEffect">
+                                <p:cTn id="70" presetID="10" presetClass="entr" presetSubtype="0" fill="hold" grpId="0" nodeType="withEffect">
                                   <p:stCondLst>
                                     <p:cond delay="0"/>
                                   </p:stCondLst>
                                   <p:childTnLst>
                                     <p:set>
                                       <p:cBhvr>
-                                        <p:cTn id="64" dur="1" fill="hold">
+                                        <p:cTn id="71" dur="1" fill="hold">
                                           <p:stCondLst>
                                             <p:cond delay="0"/>
                                           </p:stCondLst>
@@ -4868,7 +4963,7 @@
                                     </p:set>
                                     <p:animEffect transition="in" filter="fade">
                                       <p:cBhvr>
-                                        <p:cTn id="65" dur="500"/>
+                                        <p:cTn id="72" dur="500"/>
                                         <p:tgtEl>
                                           <p:spTgt spid="15"/>
                                         </p:tgtEl>
@@ -4884,26 +4979,26 @@
                     </p:cTn>
                   </p:par>
                   <p:par>
-                    <p:cTn id="66" fill="hold">
+                    <p:cTn id="73" fill="hold">
                       <p:stCondLst>
                         <p:cond delay="indefinite"/>
                       </p:stCondLst>
                       <p:childTnLst>
                         <p:par>
-                          <p:cTn id="67" fill="hold">
+                          <p:cTn id="74" fill="hold">
                             <p:stCondLst>
                               <p:cond delay="0"/>
                             </p:stCondLst>
                             <p:childTnLst>
                               <p:par>
-                                <p:cTn id="68" presetID="10" presetClass="exit" presetSubtype="0" fill="hold" grpId="1" nodeType="clickEffect">
+                                <p:cTn id="75" presetID="10" presetClass="exit" presetSubtype="0" fill="hold" grpId="1" nodeType="clickEffect">
                                   <p:stCondLst>
                                     <p:cond delay="0"/>
                                   </p:stCondLst>
                                   <p:childTnLst>
                                     <p:animEffect transition="out" filter="fade">
                                       <p:cBhvr>
-                                        <p:cTn id="69" dur="500"/>
+                                        <p:cTn id="76" dur="500"/>
                                         <p:tgtEl>
                                           <p:spTgt spid="15"/>
                                         </p:tgtEl>
@@ -4911,7 +5006,7 @@
                                     </p:animEffect>
                                     <p:set>
                                       <p:cBhvr>
-                                        <p:cTn id="70" dur="1" fill="hold">
+                                        <p:cTn id="77" dur="1" fill="hold">
                                           <p:stCondLst>
                                             <p:cond delay="499"/>
                                           </p:stCondLst>
@@ -4937,26 +5032,26 @@
                     </p:cTn>
                   </p:par>
                   <p:par>
-                    <p:cTn id="71" fill="hold">
+                    <p:cTn id="78" fill="hold">
                       <p:stCondLst>
                         <p:cond delay="indefinite"/>
                       </p:stCondLst>
                       <p:childTnLst>
                         <p:par>
-                          <p:cTn id="72" fill="hold">
+                          <p:cTn id="79" fill="hold">
                             <p:stCondLst>
                               <p:cond delay="0"/>
                             </p:stCondLst>
                             <p:childTnLst>
                               <p:par>
-                                <p:cTn id="73" presetID="26" presetClass="emph" presetSubtype="0" repeatCount="5000" fill="hold" nodeType="clickEffect">
+                                <p:cTn id="80" presetID="26" presetClass="emph" presetSubtype="0" repeatCount="5000" fill="hold" nodeType="clickEffect">
                                   <p:stCondLst>
                                     <p:cond delay="0"/>
                                   </p:stCondLst>
                                   <p:childTnLst>
                                     <p:animEffect transition="out" filter="fade">
                                       <p:cBhvr>
-                                        <p:cTn id="74" dur="1000" tmFilter="0, 0; .2, .5; .8, .5; 1, 0"/>
+                                        <p:cTn id="81" dur="1000" tmFilter="0, 0; .2, .5; .8, .5; 1, 0"/>
                                         <p:tgtEl>
                                           <p:spTgt spid="5"/>
                                         </p:tgtEl>
@@ -4964,7 +5059,7 @@
                                     </p:animEffect>
                                     <p:animScale>
                                       <p:cBhvr>
-                                        <p:cTn id="75" dur="500" autoRev="1" fill="hold"/>
+                                        <p:cTn id="82" dur="500" autoRev="1" fill="hold"/>
                                         <p:tgtEl>
                                           <p:spTgt spid="5"/>
                                         </p:tgtEl>
@@ -4975,24 +5070,20 @@
                                 </p:cTn>
                               </p:par>
                               <p:par>
-                                <p:cTn id="76" presetID="1" presetClass="entr" presetSubtype="0" fill="hold" grpId="0" nodeType="withEffect">
+                                <p:cTn id="83" presetID="10" presetClass="entr" presetSubtype="0" fill="hold" grpId="0" nodeType="withEffect">
                                   <p:stCondLst>
                                     <p:cond delay="0"/>
                                   </p:stCondLst>
                                   <p:childTnLst>
                                     <p:set>
                                       <p:cBhvr>
-                                        <p:cTn id="77" dur="1" fill="hold">
+                                        <p:cTn id="84" dur="1" fill="hold">
                                           <p:stCondLst>
                                             <p:cond delay="0"/>
                                           </p:stCondLst>
                                         </p:cTn>
                                         <p:tgtEl>
-                                          <p:spTgt spid="7">
-                                            <p:txEl>
-                                              <p:pRg st="0" end="0"/>
-                                            </p:txEl>
-                                          </p:spTgt>
+                                          <p:spTgt spid="3"/>
                                         </p:tgtEl>
                                         <p:attrNameLst>
                                           <p:attrName>style.visibility</p:attrName>
@@ -5002,130 +5093,14 @@
                                         <p:strVal val="visible"/>
                                       </p:to>
                                     </p:set>
-                                  </p:childTnLst>
-                                </p:cTn>
-                              </p:par>
-                              <p:par>
-                                <p:cTn id="78" presetID="1" presetClass="entr" presetSubtype="0" fill="hold" grpId="0" nodeType="withEffect">
-                                  <p:stCondLst>
-                                    <p:cond delay="0"/>
-                                  </p:stCondLst>
-                                  <p:childTnLst>
-                                    <p:set>
-                                      <p:cBhvr>
-                                        <p:cTn id="79" dur="1" fill="hold">
-                                          <p:stCondLst>
-                                            <p:cond delay="0"/>
-                                          </p:stCondLst>
-                                        </p:cTn>
-                                        <p:tgtEl>
-                                          <p:spTgt spid="7">
-                                            <p:txEl>
-                                              <p:pRg st="1" end="1"/>
-                                            </p:txEl>
-                                          </p:spTgt>
-                                        </p:tgtEl>
-                                        <p:attrNameLst>
-                                          <p:attrName>style.visibility</p:attrName>
-                                        </p:attrNameLst>
-                                      </p:cBhvr>
-                                      <p:to>
-                                        <p:strVal val="visible"/>
-                                      </p:to>
-                                    </p:set>
-                                  </p:childTnLst>
-                                </p:cTn>
-                              </p:par>
-                              <p:par>
-                                <p:cTn id="80" presetID="1" presetClass="entr" presetSubtype="0" fill="hold" grpId="0" nodeType="withEffect">
-                                  <p:stCondLst>
-                                    <p:cond delay="0"/>
-                                  </p:stCondLst>
-                                  <p:childTnLst>
-                                    <p:set>
-                                      <p:cBhvr>
-                                        <p:cTn id="81" dur="1" fill="hold">
-                                          <p:stCondLst>
-                                            <p:cond delay="0"/>
-                                          </p:stCondLst>
-                                        </p:cTn>
-                                        <p:tgtEl>
-                                          <p:spTgt spid="7">
-                                            <p:txEl>
-                                              <p:pRg st="2" end="2"/>
-                                            </p:txEl>
-                                          </p:spTgt>
-                                        </p:tgtEl>
-                                        <p:attrNameLst>
-                                          <p:attrName>style.visibility</p:attrName>
-                                        </p:attrNameLst>
-                                      </p:cBhvr>
-                                      <p:to>
-                                        <p:strVal val="visible"/>
-                                      </p:to>
-                                    </p:set>
-                                  </p:childTnLst>
-                                </p:cTn>
-                              </p:par>
-                              <p:par>
-                                <p:cTn id="82" presetID="1" presetClass="entr" presetSubtype="0" fill="hold" grpId="0" nodeType="withEffect">
-                                  <p:stCondLst>
-                                    <p:cond delay="0"/>
-                                  </p:stCondLst>
-                                  <p:childTnLst>
-                                    <p:set>
-                                      <p:cBhvr>
-                                        <p:cTn id="83" dur="1" fill="hold">
-                                          <p:stCondLst>
-                                            <p:cond delay="0"/>
-                                          </p:stCondLst>
-                                        </p:cTn>
-                                        <p:tgtEl>
-                                          <p:spTgt spid="7">
-                                            <p:txEl>
-                                              <p:pRg st="3" end="3"/>
-                                            </p:txEl>
-                                          </p:spTgt>
-                                        </p:tgtEl>
-                                        <p:attrNameLst>
-                                          <p:attrName>style.visibility</p:attrName>
-                                        </p:attrNameLst>
-                                      </p:cBhvr>
-                                      <p:to>
-                                        <p:strVal val="visible"/>
-                                      </p:to>
-                                    </p:set>
-                                  </p:childTnLst>
-                                </p:cTn>
-                              </p:par>
-                              <p:par>
-                                <p:cTn id="84" presetID="1" presetClass="entr" presetSubtype="0" fill="hold" grpId="0" nodeType="withEffect">
-                                  <p:stCondLst>
-                                    <p:cond delay="0"/>
-                                  </p:stCondLst>
-                                  <p:childTnLst>
-                                    <p:set>
-                                      <p:cBhvr>
-                                        <p:cTn id="85" dur="1" fill="hold">
-                                          <p:stCondLst>
-                                            <p:cond delay="0"/>
-                                          </p:stCondLst>
-                                        </p:cTn>
-                                        <p:tgtEl>
-                                          <p:spTgt spid="7">
-                                            <p:txEl>
-                                              <p:pRg st="4" end="4"/>
-                                            </p:txEl>
-                                          </p:spTgt>
-                                        </p:tgtEl>
-                                        <p:attrNameLst>
-                                          <p:attrName>style.visibility</p:attrName>
-                                        </p:attrNameLst>
-                                      </p:cBhvr>
-                                      <p:to>
-                                        <p:strVal val="visible"/>
-                                      </p:to>
-                                    </p:set>
+                                    <p:animEffect transition="in" filter="fade">
+                                      <p:cBhvr>
+                                        <p:cTn id="85" dur="500"/>
+                                        <p:tgtEl>
+                                          <p:spTgt spid="3"/>
+                                        </p:tgtEl>
+                                      </p:cBhvr>
+                                    </p:animEffect>
                                   </p:childTnLst>
                                 </p:cTn>
                               </p:par>
@@ -5157,7 +5132,6 @@
       </p:par>
     </p:tnLst>
     <p:bldLst>
-      <p:bldP spid="7" grpId="0" uiExpand="1" build="p"/>
       <p:bldP spid="8" grpId="0" animBg="1"/>
       <p:bldP spid="8" grpId="1" animBg="1"/>
       <p:bldP spid="11" grpId="0" animBg="1"/>
@@ -5169,6 +5143,7 @@
       <p:bldP spid="15" grpId="0" animBg="1"/>
       <p:bldP spid="15" grpId="1" animBg="1"/>
       <p:bldP spid="17" grpId="0" uiExpand="1" build="allAtOnce"/>
+      <p:bldP spid="3" grpId="0" animBg="1"/>
     </p:bldLst>
   </p:timing>
 </p:sld>
@@ -7151,6 +7126,74 @@
           </a:fontRef>
         </p:style>
       </p:cxnSp>
+      <p:sp>
+        <p:nvSpPr>
+          <p:cNvPr id="2" name="Rectangle 1">
+            <a:extLst>
+              <a:ext uri="{FF2B5EF4-FFF2-40B4-BE49-F238E27FC236}">
+                <a16:creationId xmlns:a16="http://schemas.microsoft.com/office/drawing/2014/main" id="{05C55EE9-FF0C-41BD-553D-2460A49FD8F7}"/>
+              </a:ext>
+            </a:extLst>
+          </p:cNvPr>
+          <p:cNvSpPr/>
+          <p:nvPr/>
+        </p:nvSpPr>
+        <p:spPr>
+          <a:xfrm>
+            <a:off x="713677" y="5056187"/>
+            <a:ext cx="7605569" cy="1321212"/>
+          </a:xfrm>
+          <a:prstGeom prst="rect">
+            <a:avLst/>
+          </a:prstGeom>
+          <a:noFill/>
+          <a:effectLst>
+            <a:glow rad="63500">
+              <a:schemeClr val="accent4">
+                <a:satMod val="175000"/>
+                <a:alpha val="40000"/>
+              </a:schemeClr>
+            </a:glow>
+          </a:effectLst>
+        </p:spPr>
+        <p:style>
+          <a:lnRef idx="2">
+            <a:schemeClr val="accent6"/>
+          </a:lnRef>
+          <a:fillRef idx="1">
+            <a:schemeClr val="lt1"/>
+          </a:fillRef>
+          <a:effectRef idx="0">
+            <a:schemeClr val="accent6"/>
+          </a:effectRef>
+          <a:fontRef idx="minor">
+            <a:schemeClr val="dk1"/>
+          </a:fontRef>
+        </p:style>
+        <p:txBody>
+          <a:bodyPr rtlCol="0" anchor="t"/>
+          <a:lstStyle/>
+          <a:p>
+            <a:pPr algn="ctr"/>
+            <a:r>
+              <a:rPr lang="en-GB" dirty="0">
+                <a:solidFill>
+                  <a:schemeClr val="accent6"/>
+                </a:solidFill>
+                <a:effectLst>
+                  <a:glow rad="228600">
+                    <a:schemeClr val="accent4">
+                      <a:satMod val="175000"/>
+                      <a:alpha val="40000"/>
+                    </a:schemeClr>
+                  </a:glow>
+                </a:effectLst>
+              </a:rPr>
+              <a:t>				AI Services</a:t>
+            </a:r>
+          </a:p>
+        </p:txBody>
+      </p:sp>
     </p:spTree>
     <p:extLst>
       <p:ext uri="{BB962C8B-B14F-4D97-AF65-F5344CB8AC3E}">
@@ -7639,7 +7682,7 @@
                             </p:stCondLst>
                             <p:childTnLst>
                               <p:par>
-                                <p:cTn id="46" presetID="10" presetClass="entr" presetSubtype="0" fill="hold" nodeType="clickEffect">
+                                <p:cTn id="46" presetID="10" presetClass="entr" presetSubtype="0" fill="hold" grpId="0" nodeType="clickEffect">
                                   <p:stCondLst>
                                     <p:cond delay="0"/>
                                   </p:stCondLst>
@@ -7652,7 +7695,7 @@
                                           </p:stCondLst>
                                         </p:cTn>
                                         <p:tgtEl>
-                                          <p:spTgt spid="60"/>
+                                          <p:spTgt spid="2"/>
                                         </p:tgtEl>
                                         <p:attrNameLst>
                                           <p:attrName>style.visibility</p:attrName>
@@ -7666,42 +7709,7 @@
                                       <p:cBhvr>
                                         <p:cTn id="48" dur="500"/>
                                         <p:tgtEl>
-                                          <p:spTgt spid="60"/>
-                                        </p:tgtEl>
-                                      </p:cBhvr>
-                                    </p:animEffect>
-                                  </p:childTnLst>
-                                </p:cTn>
-                              </p:par>
-                              <p:par>
-                                <p:cTn id="49" presetID="10" presetClass="entr" presetSubtype="0" fill="hold" grpId="0" nodeType="withEffect">
-                                  <p:stCondLst>
-                                    <p:cond delay="0"/>
-                                  </p:stCondLst>
-                                  <p:childTnLst>
-                                    <p:set>
-                                      <p:cBhvr>
-                                        <p:cTn id="50" dur="1" fill="hold">
-                                          <p:stCondLst>
-                                            <p:cond delay="0"/>
-                                          </p:stCondLst>
-                                        </p:cTn>
-                                        <p:tgtEl>
-                                          <p:spTgt spid="61"/>
-                                        </p:tgtEl>
-                                        <p:attrNameLst>
-                                          <p:attrName>style.visibility</p:attrName>
-                                        </p:attrNameLst>
-                                      </p:cBhvr>
-                                      <p:to>
-                                        <p:strVal val="visible"/>
-                                      </p:to>
-                                    </p:set>
-                                    <p:animEffect transition="in" filter="fade">
-                                      <p:cBhvr>
-                                        <p:cTn id="51" dur="500"/>
-                                        <p:tgtEl>
-                                          <p:spTgt spid="61"/>
+                                          <p:spTgt spid="2"/>
                                         </p:tgtEl>
                                       </p:cBhvr>
                                     </p:animEffect>
@@ -7715,32 +7723,85 @@
                     </p:cTn>
                   </p:par>
                   <p:par>
-                    <p:cTn id="52" fill="hold">
+                    <p:cTn id="49" fill="hold">
                       <p:stCondLst>
                         <p:cond delay="indefinite"/>
                       </p:stCondLst>
                       <p:childTnLst>
                         <p:par>
-                          <p:cTn id="53" fill="hold">
+                          <p:cTn id="50" fill="hold">
                             <p:stCondLst>
                               <p:cond delay="0"/>
                             </p:stCondLst>
                             <p:childTnLst>
                               <p:par>
-                                <p:cTn id="54" presetID="10" presetClass="entr" presetSubtype="0" fill="hold" nodeType="clickEffect">
+                                <p:cTn id="51" presetID="10" presetClass="exit" presetSubtype="0" fill="hold" grpId="1" nodeType="clickEffect">
+                                  <p:stCondLst>
+                                    <p:cond delay="0"/>
+                                  </p:stCondLst>
+                                  <p:childTnLst>
+                                    <p:animEffect transition="out" filter="fade">
+                                      <p:cBhvr>
+                                        <p:cTn id="52" dur="500"/>
+                                        <p:tgtEl>
+                                          <p:spTgt spid="2"/>
+                                        </p:tgtEl>
+                                      </p:cBhvr>
+                                    </p:animEffect>
+                                    <p:set>
+                                      <p:cBhvr>
+                                        <p:cTn id="53" dur="1" fill="hold">
+                                          <p:stCondLst>
+                                            <p:cond delay="499"/>
+                                          </p:stCondLst>
+                                        </p:cTn>
+                                        <p:tgtEl>
+                                          <p:spTgt spid="2"/>
+                                        </p:tgtEl>
+                                        <p:attrNameLst>
+                                          <p:attrName>style.visibility</p:attrName>
+                                        </p:attrNameLst>
+                                      </p:cBhvr>
+                                      <p:to>
+                                        <p:strVal val="hidden"/>
+                                      </p:to>
+                                    </p:set>
+                                  </p:childTnLst>
+                                </p:cTn>
+                              </p:par>
+                            </p:childTnLst>
+                          </p:cTn>
+                        </p:par>
+                      </p:childTnLst>
+                    </p:cTn>
+                  </p:par>
+                  <p:par>
+                    <p:cTn id="54" fill="hold">
+                      <p:stCondLst>
+                        <p:cond delay="indefinite"/>
+                      </p:stCondLst>
+                      <p:childTnLst>
+                        <p:par>
+                          <p:cTn id="55" fill="hold">
+                            <p:stCondLst>
+                              <p:cond delay="0"/>
+                            </p:stCondLst>
+                            <p:childTnLst>
+                              <p:par>
+                                <p:cTn id="56" presetID="10" presetClass="entr" presetSubtype="0" fill="hold" nodeType="clickEffect">
                                   <p:stCondLst>
                                     <p:cond delay="0"/>
                                   </p:stCondLst>
                                   <p:childTnLst>
                                     <p:set>
                                       <p:cBhvr>
-                                        <p:cTn id="55" dur="1" fill="hold">
+                                        <p:cTn id="57" dur="1" fill="hold">
                                           <p:stCondLst>
                                             <p:cond delay="0"/>
                                           </p:stCondLst>
                                         </p:cTn>
                                         <p:tgtEl>
-                                          <p:spTgt spid="77"/>
+                                          <p:spTgt spid="60"/>
                                         </p:tgtEl>
                                         <p:attrNameLst>
                                           <p:attrName>style.visibility</p:attrName>
@@ -7752,7 +7813,95 @@
                                     </p:set>
                                     <p:animEffect transition="in" filter="fade">
                                       <p:cBhvr>
-                                        <p:cTn id="56" dur="500"/>
+                                        <p:cTn id="58" dur="500"/>
+                                        <p:tgtEl>
+                                          <p:spTgt spid="60"/>
+                                        </p:tgtEl>
+                                      </p:cBhvr>
+                                    </p:animEffect>
+                                  </p:childTnLst>
+                                </p:cTn>
+                              </p:par>
+                              <p:par>
+                                <p:cTn id="59" presetID="10" presetClass="entr" presetSubtype="0" fill="hold" grpId="0" nodeType="withEffect">
+                                  <p:stCondLst>
+                                    <p:cond delay="0"/>
+                                  </p:stCondLst>
+                                  <p:childTnLst>
+                                    <p:set>
+                                      <p:cBhvr>
+                                        <p:cTn id="60" dur="1" fill="hold">
+                                          <p:stCondLst>
+                                            <p:cond delay="0"/>
+                                          </p:stCondLst>
+                                        </p:cTn>
+                                        <p:tgtEl>
+                                          <p:spTgt spid="61"/>
+                                        </p:tgtEl>
+                                        <p:attrNameLst>
+                                          <p:attrName>style.visibility</p:attrName>
+                                        </p:attrNameLst>
+                                      </p:cBhvr>
+                                      <p:to>
+                                        <p:strVal val="visible"/>
+                                      </p:to>
+                                    </p:set>
+                                    <p:animEffect transition="in" filter="fade">
+                                      <p:cBhvr>
+                                        <p:cTn id="61" dur="500"/>
+                                        <p:tgtEl>
+                                          <p:spTgt spid="61"/>
+                                        </p:tgtEl>
+                                      </p:cBhvr>
+                                    </p:animEffect>
+                                  </p:childTnLst>
+                                </p:cTn>
+                              </p:par>
+                            </p:childTnLst>
+                          </p:cTn>
+                        </p:par>
+                      </p:childTnLst>
+                    </p:cTn>
+                  </p:par>
+                  <p:par>
+                    <p:cTn id="62" fill="hold">
+                      <p:stCondLst>
+                        <p:cond delay="indefinite"/>
+                      </p:stCondLst>
+                      <p:childTnLst>
+                        <p:par>
+                          <p:cTn id="63" fill="hold">
+                            <p:stCondLst>
+                              <p:cond delay="0"/>
+                            </p:stCondLst>
+                            <p:childTnLst>
+                              <p:par>
+                                <p:cTn id="64" presetID="10" presetClass="entr" presetSubtype="0" fill="hold" nodeType="clickEffect">
+                                  <p:stCondLst>
+                                    <p:cond delay="0"/>
+                                  </p:stCondLst>
+                                  <p:childTnLst>
+                                    <p:set>
+                                      <p:cBhvr>
+                                        <p:cTn id="65" dur="1" fill="hold">
+                                          <p:stCondLst>
+                                            <p:cond delay="0"/>
+                                          </p:stCondLst>
+                                        </p:cTn>
+                                        <p:tgtEl>
+                                          <p:spTgt spid="77"/>
+                                        </p:tgtEl>
+                                        <p:attrNameLst>
+                                          <p:attrName>style.visibility</p:attrName>
+                                        </p:attrNameLst>
+                                      </p:cBhvr>
+                                      <p:to>
+                                        <p:strVal val="visible"/>
+                                      </p:to>
+                                    </p:set>
+                                    <p:animEffect transition="in" filter="fade">
+                                      <p:cBhvr>
+                                        <p:cTn id="66" dur="500"/>
                                         <p:tgtEl>
                                           <p:spTgt spid="77"/>
                                         </p:tgtEl>
@@ -7796,6 +7945,8 @@
       <p:bldP spid="61" grpId="0" animBg="1"/>
       <p:bldP spid="68" grpId="0"/>
       <p:bldP spid="70" grpId="0" animBg="1"/>
+      <p:bldP spid="2" grpId="0" animBg="1"/>
+      <p:bldP spid="2" grpId="1" animBg="1"/>
     </p:bldLst>
   </p:timing>
 </p:sld>
@@ -7846,7 +7997,7 @@
         </p:blipFill>
         <p:spPr>
           <a:xfrm>
-            <a:off x="1118493" y="480601"/>
+            <a:off x="1118493" y="435330"/>
             <a:ext cx="9955014" cy="5896798"/>
           </a:xfrm>
           <a:prstGeom prst="rect">
@@ -8301,7 +8452,7 @@
             </a:solidFill>
           </a:ln>
           <a:effectLst>
-            <a:glow rad="63500">
+            <a:glow rad="228600">
               <a:schemeClr val="accent4">
                 <a:satMod val="175000"/>
                 <a:alpha val="40000"/>
@@ -8333,7 +8484,7 @@
                   <a:srgbClr val="00B050"/>
                 </a:solidFill>
                 <a:effectLst>
-                  <a:glow rad="63500">
+                  <a:glow rad="228600">
                     <a:schemeClr val="accent4">
                       <a:satMod val="175000"/>
                       <a:alpha val="40000"/>
@@ -8580,15 +8731,15 @@
         <p:spPr>
           <a:xfrm>
             <a:off x="1279128" y="5583648"/>
-            <a:ext cx="917972" cy="671101"/>
+            <a:ext cx="746896" cy="671101"/>
           </a:xfrm>
           <a:prstGeom prst="rect">
             <a:avLst/>
           </a:prstGeom>
           <a:noFill/>
           <a:effectLst>
-            <a:glow rad="228600">
-              <a:schemeClr val="accent2">
+            <a:glow rad="63500">
+              <a:schemeClr val="accent4">
                 <a:satMod val="175000"/>
                 <a:alpha val="40000"/>
               </a:schemeClr>
@@ -8731,6 +8882,552 @@
           </a:p>
         </p:txBody>
       </p:sp>
+      <p:cxnSp>
+        <p:nvCxnSpPr>
+          <p:cNvPr id="9" name="Straight Arrow Connector 8">
+            <a:extLst>
+              <a:ext uri="{FF2B5EF4-FFF2-40B4-BE49-F238E27FC236}">
+                <a16:creationId xmlns:a16="http://schemas.microsoft.com/office/drawing/2014/main" id="{F972C163-AE79-D944-C2BA-14888C7EC3F4}"/>
+              </a:ext>
+            </a:extLst>
+          </p:cNvPr>
+          <p:cNvCxnSpPr>
+            <a:cxnSpLocks/>
+          </p:cNvCxnSpPr>
+          <p:nvPr/>
+        </p:nvCxnSpPr>
+        <p:spPr>
+          <a:xfrm>
+            <a:off x="1645920" y="6185647"/>
+            <a:ext cx="992505" cy="0"/>
+          </a:xfrm>
+          <a:prstGeom prst="straightConnector1">
+            <a:avLst/>
+          </a:prstGeom>
+          <a:ln>
+            <a:solidFill>
+              <a:srgbClr val="00B050"/>
+            </a:solidFill>
+            <a:prstDash val="dash"/>
+            <a:tailEnd type="triangle"/>
+          </a:ln>
+          <a:effectLst>
+            <a:glow rad="228600">
+              <a:schemeClr val="accent2">
+                <a:satMod val="175000"/>
+                <a:alpha val="40000"/>
+              </a:schemeClr>
+            </a:glow>
+          </a:effectLst>
+        </p:spPr>
+        <p:style>
+          <a:lnRef idx="3">
+            <a:schemeClr val="accent6"/>
+          </a:lnRef>
+          <a:fillRef idx="0">
+            <a:schemeClr val="accent6"/>
+          </a:fillRef>
+          <a:effectRef idx="2">
+            <a:schemeClr val="accent6"/>
+          </a:effectRef>
+          <a:fontRef idx="minor">
+            <a:schemeClr val="tx1"/>
+          </a:fontRef>
+        </p:style>
+      </p:cxnSp>
+      <p:sp>
+        <p:nvSpPr>
+          <p:cNvPr id="12" name="Rectangle 11">
+            <a:extLst>
+              <a:ext uri="{FF2B5EF4-FFF2-40B4-BE49-F238E27FC236}">
+                <a16:creationId xmlns:a16="http://schemas.microsoft.com/office/drawing/2014/main" id="{EB774B0B-8A00-FDC7-A976-CDF0A4D15F62}"/>
+              </a:ext>
+            </a:extLst>
+          </p:cNvPr>
+          <p:cNvSpPr/>
+          <p:nvPr/>
+        </p:nvSpPr>
+        <p:spPr>
+          <a:xfrm>
+            <a:off x="2159794" y="5583648"/>
+            <a:ext cx="1327351" cy="692150"/>
+          </a:xfrm>
+          <a:prstGeom prst="rect">
+            <a:avLst/>
+          </a:prstGeom>
+          <a:noFill/>
+          <a:effectLst>
+            <a:glow rad="63500">
+              <a:schemeClr val="accent4">
+                <a:satMod val="175000"/>
+                <a:alpha val="40000"/>
+              </a:schemeClr>
+            </a:glow>
+          </a:effectLst>
+        </p:spPr>
+        <p:style>
+          <a:lnRef idx="2">
+            <a:schemeClr val="accent6"/>
+          </a:lnRef>
+          <a:fillRef idx="1">
+            <a:schemeClr val="lt1"/>
+          </a:fillRef>
+          <a:effectRef idx="0">
+            <a:schemeClr val="accent6"/>
+          </a:effectRef>
+          <a:fontRef idx="minor">
+            <a:schemeClr val="dk1"/>
+          </a:fontRef>
+        </p:style>
+        <p:txBody>
+          <a:bodyPr rtlCol="0" anchor="ctr"/>
+          <a:lstStyle/>
+          <a:p>
+            <a:pPr algn="ctr"/>
+            <a:endParaRPr lang="en-GB"/>
+          </a:p>
+        </p:txBody>
+      </p:sp>
+      <p:cxnSp>
+        <p:nvCxnSpPr>
+          <p:cNvPr id="15" name="Straight Arrow Connector 14">
+            <a:extLst>
+              <a:ext uri="{FF2B5EF4-FFF2-40B4-BE49-F238E27FC236}">
+                <a16:creationId xmlns:a16="http://schemas.microsoft.com/office/drawing/2014/main" id="{BB08B75A-0208-C693-0812-71F2E1715C1A}"/>
+              </a:ext>
+            </a:extLst>
+          </p:cNvPr>
+          <p:cNvCxnSpPr>
+            <a:cxnSpLocks/>
+          </p:cNvCxnSpPr>
+          <p:nvPr/>
+        </p:nvCxnSpPr>
+        <p:spPr>
+          <a:xfrm flipH="1" flipV="1">
+            <a:off x="3238500" y="4678680"/>
+            <a:ext cx="106680" cy="904968"/>
+          </a:xfrm>
+          <a:prstGeom prst="straightConnector1">
+            <a:avLst/>
+          </a:prstGeom>
+          <a:ln>
+            <a:solidFill>
+              <a:srgbClr val="00B050"/>
+            </a:solidFill>
+            <a:prstDash val="dash"/>
+            <a:tailEnd type="triangle"/>
+          </a:ln>
+          <a:effectLst>
+            <a:glow rad="228600">
+              <a:schemeClr val="accent2">
+                <a:satMod val="175000"/>
+                <a:alpha val="40000"/>
+              </a:schemeClr>
+            </a:glow>
+          </a:effectLst>
+        </p:spPr>
+        <p:style>
+          <a:lnRef idx="3">
+            <a:schemeClr val="accent6"/>
+          </a:lnRef>
+          <a:fillRef idx="0">
+            <a:schemeClr val="accent6"/>
+          </a:fillRef>
+          <a:effectRef idx="2">
+            <a:schemeClr val="accent6"/>
+          </a:effectRef>
+          <a:fontRef idx="minor">
+            <a:schemeClr val="tx1"/>
+          </a:fontRef>
+        </p:style>
+      </p:cxnSp>
+      <p:sp>
+        <p:nvSpPr>
+          <p:cNvPr id="23" name="Rectangle 22">
+            <a:extLst>
+              <a:ext uri="{FF2B5EF4-FFF2-40B4-BE49-F238E27FC236}">
+                <a16:creationId xmlns:a16="http://schemas.microsoft.com/office/drawing/2014/main" id="{89C19A4C-7A3B-8BE9-F444-D7EF3ACB9021}"/>
+              </a:ext>
+            </a:extLst>
+          </p:cNvPr>
+          <p:cNvSpPr/>
+          <p:nvPr/>
+        </p:nvSpPr>
+        <p:spPr>
+          <a:xfrm>
+            <a:off x="822960" y="4942200"/>
+            <a:ext cx="5533015" cy="1486633"/>
+          </a:xfrm>
+          <a:prstGeom prst="rect">
+            <a:avLst/>
+          </a:prstGeom>
+          <a:noFill/>
+          <a:ln>
+            <a:solidFill>
+              <a:srgbClr val="00B050"/>
+            </a:solidFill>
+          </a:ln>
+          <a:effectLst>
+            <a:glow rad="228600">
+              <a:schemeClr val="accent4">
+                <a:satMod val="175000"/>
+                <a:alpha val="40000"/>
+              </a:schemeClr>
+            </a:glow>
+          </a:effectLst>
+        </p:spPr>
+        <p:style>
+          <a:lnRef idx="2">
+            <a:schemeClr val="accent6"/>
+          </a:lnRef>
+          <a:fillRef idx="1">
+            <a:schemeClr val="lt1"/>
+          </a:fillRef>
+          <a:effectRef idx="0">
+            <a:schemeClr val="accent6"/>
+          </a:effectRef>
+          <a:fontRef idx="minor">
+            <a:schemeClr val="dk1"/>
+          </a:fontRef>
+        </p:style>
+        <p:txBody>
+          <a:bodyPr rtlCol="0" anchor="ctr"/>
+          <a:lstStyle/>
+          <a:p>
+            <a:r>
+              <a:rPr lang="en-GB" sz="1400" dirty="0">
+                <a:solidFill>
+                  <a:srgbClr val="00B050"/>
+                </a:solidFill>
+                <a:effectLst>
+                  <a:glow rad="63500">
+                    <a:schemeClr val="accent4">
+                      <a:satMod val="175000"/>
+                      <a:alpha val="40000"/>
+                    </a:schemeClr>
+                  </a:glow>
+                </a:effectLst>
+              </a:rPr>
+              <a:t>				</a:t>
+            </a:r>
+            <a:r>
+              <a:rPr lang="en-GB" sz="1400" dirty="0">
+                <a:solidFill>
+                  <a:srgbClr val="00B050"/>
+                </a:solidFill>
+                <a:effectLst>
+                  <a:glow rad="228600">
+                    <a:schemeClr val="accent4">
+                      <a:satMod val="175000"/>
+                      <a:alpha val="40000"/>
+                    </a:schemeClr>
+                  </a:glow>
+                </a:effectLst>
+              </a:rPr>
+              <a:t>AI Service</a:t>
+            </a:r>
+          </a:p>
+          <a:p>
+            <a:pPr algn="ctr"/>
+            <a:endParaRPr lang="en-GB" sz="1400" dirty="0">
+              <a:solidFill>
+                <a:srgbClr val="00B050"/>
+              </a:solidFill>
+            </a:endParaRPr>
+          </a:p>
+          <a:p>
+            <a:pPr algn="ctr"/>
+            <a:endParaRPr lang="en-GB" sz="1400" dirty="0">
+              <a:solidFill>
+                <a:srgbClr val="00B050"/>
+              </a:solidFill>
+            </a:endParaRPr>
+          </a:p>
+          <a:p>
+            <a:pPr algn="ctr"/>
+            <a:endParaRPr lang="en-GB" sz="1400" dirty="0">
+              <a:solidFill>
+                <a:srgbClr val="00B050"/>
+              </a:solidFill>
+            </a:endParaRPr>
+          </a:p>
+          <a:p>
+            <a:pPr algn="ctr"/>
+            <a:endParaRPr lang="en-GB" sz="1400" dirty="0">
+              <a:solidFill>
+                <a:srgbClr val="00B050"/>
+              </a:solidFill>
+            </a:endParaRPr>
+          </a:p>
+          <a:p>
+            <a:pPr algn="ctr"/>
+            <a:endParaRPr lang="en-GB" sz="1400" dirty="0">
+              <a:solidFill>
+                <a:srgbClr val="00B050"/>
+              </a:solidFill>
+            </a:endParaRPr>
+          </a:p>
+          <a:p>
+            <a:pPr algn="ctr"/>
+            <a:endParaRPr lang="en-GB" sz="1400" dirty="0">
+              <a:solidFill>
+                <a:srgbClr val="00B050"/>
+              </a:solidFill>
+            </a:endParaRPr>
+          </a:p>
+          <a:p>
+            <a:pPr algn="ctr"/>
+            <a:endParaRPr lang="en-GB" sz="1400" dirty="0">
+              <a:solidFill>
+                <a:srgbClr val="00B050"/>
+              </a:solidFill>
+            </a:endParaRPr>
+          </a:p>
+          <a:p>
+            <a:pPr algn="ctr"/>
+            <a:endParaRPr lang="en-GB" sz="1400" dirty="0">
+              <a:solidFill>
+                <a:srgbClr val="00B050"/>
+              </a:solidFill>
+            </a:endParaRPr>
+          </a:p>
+          <a:p>
+            <a:pPr algn="ctr"/>
+            <a:endParaRPr lang="en-GB" sz="1400" dirty="0">
+              <a:solidFill>
+                <a:srgbClr val="00B050"/>
+              </a:solidFill>
+            </a:endParaRPr>
+          </a:p>
+        </p:txBody>
+      </p:sp>
+      <p:sp>
+        <p:nvSpPr>
+          <p:cNvPr id="24" name="Speech Bubble: Oval 23">
+            <a:extLst>
+              <a:ext uri="{FF2B5EF4-FFF2-40B4-BE49-F238E27FC236}">
+                <a16:creationId xmlns:a16="http://schemas.microsoft.com/office/drawing/2014/main" id="{4C08F1ED-571C-5449-B76F-18A160569BF8}"/>
+              </a:ext>
+            </a:extLst>
+          </p:cNvPr>
+          <p:cNvSpPr/>
+          <p:nvPr/>
+        </p:nvSpPr>
+        <p:spPr>
+          <a:xfrm>
+            <a:off x="7102497" y="4517343"/>
+            <a:ext cx="2485373" cy="546100"/>
+          </a:xfrm>
+          <a:prstGeom prst="wedgeEllipseCallout">
+            <a:avLst>
+              <a:gd name="adj1" fmla="val -204998"/>
+              <a:gd name="adj2" fmla="val -68"/>
+            </a:avLst>
+          </a:prstGeom>
+          <a:noFill/>
+        </p:spPr>
+        <p:style>
+          <a:lnRef idx="2">
+            <a:schemeClr val="accent6"/>
+          </a:lnRef>
+          <a:fillRef idx="1">
+            <a:schemeClr val="lt1"/>
+          </a:fillRef>
+          <a:effectRef idx="0">
+            <a:schemeClr val="accent6"/>
+          </a:effectRef>
+          <a:fontRef idx="minor">
+            <a:schemeClr val="dk1"/>
+          </a:fontRef>
+        </p:style>
+        <p:txBody>
+          <a:bodyPr rtlCol="0" anchor="ctr"/>
+          <a:lstStyle/>
+          <a:p>
+            <a:pPr algn="ctr"/>
+            <a:r>
+              <a:rPr lang="en-GB" dirty="0">
+                <a:solidFill>
+                  <a:schemeClr val="accent6"/>
+                </a:solidFill>
+              </a:rPr>
+              <a:t>doc-processed</a:t>
+            </a:r>
+          </a:p>
+        </p:txBody>
+      </p:sp>
+      <p:sp>
+        <p:nvSpPr>
+          <p:cNvPr id="26" name="Speech Bubble: Oval 25">
+            <a:extLst>
+              <a:ext uri="{FF2B5EF4-FFF2-40B4-BE49-F238E27FC236}">
+                <a16:creationId xmlns:a16="http://schemas.microsoft.com/office/drawing/2014/main" id="{B1EE40D8-E0A8-A01B-B7B9-C4452B588DE6}"/>
+              </a:ext>
+            </a:extLst>
+          </p:cNvPr>
+          <p:cNvSpPr/>
+          <p:nvPr/>
+        </p:nvSpPr>
+        <p:spPr>
+          <a:xfrm>
+            <a:off x="7351141" y="3794759"/>
+            <a:ext cx="2485373" cy="546100"/>
+          </a:xfrm>
+          <a:prstGeom prst="wedgeEllipseCallout">
+            <a:avLst>
+              <a:gd name="adj1" fmla="val -239625"/>
+              <a:gd name="adj2" fmla="val 29480"/>
+            </a:avLst>
+          </a:prstGeom>
+          <a:noFill/>
+        </p:spPr>
+        <p:style>
+          <a:lnRef idx="2">
+            <a:schemeClr val="accent6"/>
+          </a:lnRef>
+          <a:fillRef idx="1">
+            <a:schemeClr val="lt1"/>
+          </a:fillRef>
+          <a:effectRef idx="0">
+            <a:schemeClr val="accent6"/>
+          </a:effectRef>
+          <a:fontRef idx="minor">
+            <a:schemeClr val="dk1"/>
+          </a:fontRef>
+        </p:style>
+        <p:txBody>
+          <a:bodyPr rtlCol="0" anchor="ctr"/>
+          <a:lstStyle/>
+          <a:p>
+            <a:pPr algn="ctr"/>
+            <a:r>
+              <a:rPr lang="en-GB" dirty="0">
+                <a:solidFill>
+                  <a:schemeClr val="accent6"/>
+                </a:solidFill>
+              </a:rPr>
+              <a:t>doc-uploaded</a:t>
+            </a:r>
+          </a:p>
+        </p:txBody>
+      </p:sp>
+      <p:sp>
+        <p:nvSpPr>
+          <p:cNvPr id="10" name="Rectangle 9">
+            <a:extLst>
+              <a:ext uri="{FF2B5EF4-FFF2-40B4-BE49-F238E27FC236}">
+                <a16:creationId xmlns:a16="http://schemas.microsoft.com/office/drawing/2014/main" id="{746EA9E6-7484-9FDC-3D67-EEEE91F7A863}"/>
+              </a:ext>
+            </a:extLst>
+          </p:cNvPr>
+          <p:cNvSpPr/>
+          <p:nvPr/>
+        </p:nvSpPr>
+        <p:spPr>
+          <a:xfrm>
+            <a:off x="3433407" y="1285120"/>
+            <a:ext cx="2922568" cy="729100"/>
+          </a:xfrm>
+          <a:prstGeom prst="rect">
+            <a:avLst/>
+          </a:prstGeom>
+          <a:noFill/>
+          <a:ln>
+            <a:solidFill>
+              <a:srgbClr val="00B050"/>
+            </a:solidFill>
+          </a:ln>
+          <a:effectLst>
+            <a:glow rad="228600">
+              <a:schemeClr val="accent4">
+                <a:satMod val="175000"/>
+                <a:alpha val="40000"/>
+              </a:schemeClr>
+            </a:glow>
+          </a:effectLst>
+        </p:spPr>
+        <p:style>
+          <a:lnRef idx="2">
+            <a:schemeClr val="accent6"/>
+          </a:lnRef>
+          <a:fillRef idx="1">
+            <a:schemeClr val="lt1"/>
+          </a:fillRef>
+          <a:effectRef idx="0">
+            <a:schemeClr val="accent6"/>
+          </a:effectRef>
+          <a:fontRef idx="minor">
+            <a:schemeClr val="dk1"/>
+          </a:fontRef>
+        </p:style>
+        <p:txBody>
+          <a:bodyPr rtlCol="0" anchor="ctr"/>
+          <a:lstStyle/>
+          <a:p>
+            <a:r>
+              <a:rPr lang="en-GB" sz="1400" dirty="0">
+                <a:solidFill>
+                  <a:srgbClr val="00B050"/>
+                </a:solidFill>
+                <a:effectLst>
+                  <a:glow rad="228600">
+                    <a:schemeClr val="accent4">
+                      <a:satMod val="175000"/>
+                      <a:alpha val="40000"/>
+                    </a:schemeClr>
+                  </a:glow>
+                </a:effectLst>
+              </a:rPr>
+              <a:t>Coming soon - UI</a:t>
+            </a:r>
+            <a:endParaRPr lang="en-GB" sz="1400" dirty="0">
+              <a:solidFill>
+                <a:srgbClr val="00B050"/>
+              </a:solidFill>
+            </a:endParaRPr>
+          </a:p>
+          <a:p>
+            <a:pPr algn="ctr"/>
+            <a:endParaRPr lang="en-GB" sz="1400" dirty="0">
+              <a:solidFill>
+                <a:srgbClr val="00B050"/>
+              </a:solidFill>
+            </a:endParaRPr>
+          </a:p>
+          <a:p>
+            <a:pPr algn="ctr"/>
+            <a:endParaRPr lang="en-GB" sz="1400" dirty="0">
+              <a:solidFill>
+                <a:srgbClr val="00B050"/>
+              </a:solidFill>
+            </a:endParaRPr>
+          </a:p>
+          <a:p>
+            <a:pPr algn="ctr"/>
+            <a:endParaRPr lang="en-GB" sz="1400" dirty="0">
+              <a:solidFill>
+                <a:srgbClr val="00B050"/>
+              </a:solidFill>
+            </a:endParaRPr>
+          </a:p>
+          <a:p>
+            <a:pPr algn="ctr"/>
+            <a:endParaRPr lang="en-GB" sz="1400" dirty="0">
+              <a:solidFill>
+                <a:srgbClr val="00B050"/>
+              </a:solidFill>
+            </a:endParaRPr>
+          </a:p>
+          <a:p>
+            <a:pPr algn="ctr"/>
+            <a:endParaRPr lang="en-GB" sz="1400" dirty="0">
+              <a:solidFill>
+                <a:srgbClr val="00B050"/>
+              </a:solidFill>
+            </a:endParaRPr>
+          </a:p>
+        </p:txBody>
+      </p:sp>
     </p:spTree>
     <p:extLst>
       <p:ext uri="{BB962C8B-B14F-4D97-AF65-F5344CB8AC3E}">
@@ -8831,7 +9528,9 @@
                                           </p:stCondLst>
                                         </p:cTn>
                                         <p:tgtEl>
-                                          <p:spTgt spid="2"/>
+                                          <p:spTgt spid="2">
+                                            <p:bg/>
+                                          </p:spTgt>
                                         </p:tgtEl>
                                         <p:attrNameLst>
                                           <p:attrName>style.visibility</p:attrName>
@@ -8843,9 +9542,136 @@
                                     </p:set>
                                     <p:animEffect transition="in" filter="fade">
                                       <p:cBhvr>
-                                        <p:cTn id="12" dur="500"/>
-                                        <p:tgtEl>
-                                          <p:spTgt spid="2"/>
+                                        <p:cTn id="12" dur="1000"/>
+                                        <p:tgtEl>
+                                          <p:spTgt spid="2">
+                                            <p:bg/>
+                                          </p:spTgt>
+                                        </p:tgtEl>
+                                      </p:cBhvr>
+                                    </p:animEffect>
+                                  </p:childTnLst>
+                                </p:cTn>
+                              </p:par>
+                              <p:par>
+                                <p:cTn id="13" presetID="10" presetClass="entr" presetSubtype="0" fill="hold" grpId="1" nodeType="withEffect">
+                                  <p:stCondLst>
+                                    <p:cond delay="0"/>
+                                  </p:stCondLst>
+                                  <p:childTnLst>
+                                    <p:set>
+                                      <p:cBhvr>
+                                        <p:cTn id="14" dur="1" fill="hold">
+                                          <p:stCondLst>
+                                            <p:cond delay="0"/>
+                                          </p:stCondLst>
+                                        </p:cTn>
+                                        <p:tgtEl>
+                                          <p:spTgt spid="2">
+                                            <p:txEl>
+                                              <p:pRg st="0" end="0"/>
+                                            </p:txEl>
+                                          </p:spTgt>
+                                        </p:tgtEl>
+                                        <p:attrNameLst>
+                                          <p:attrName>style.visibility</p:attrName>
+                                        </p:attrNameLst>
+                                      </p:cBhvr>
+                                      <p:to>
+                                        <p:strVal val="visible"/>
+                                      </p:to>
+                                    </p:set>
+                                    <p:animEffect transition="in" filter="fade">
+                                      <p:cBhvr>
+                                        <p:cTn id="15" dur="1000"/>
+                                        <p:tgtEl>
+                                          <p:spTgt spid="2">
+                                            <p:txEl>
+                                              <p:pRg st="0" end="0"/>
+                                            </p:txEl>
+                                          </p:spTgt>
+                                        </p:tgtEl>
+                                      </p:cBhvr>
+                                    </p:animEffect>
+                                  </p:childTnLst>
+                                </p:cTn>
+                              </p:par>
+                              <p:par>
+                                <p:cTn id="16" presetID="10" presetClass="entr" presetSubtype="0" fill="hold" grpId="1" nodeType="withEffect">
+                                  <p:stCondLst>
+                                    <p:cond delay="0"/>
+                                  </p:stCondLst>
+                                  <p:childTnLst>
+                                    <p:set>
+                                      <p:cBhvr>
+                                        <p:cTn id="17" dur="1" fill="hold">
+                                          <p:stCondLst>
+                                            <p:cond delay="0"/>
+                                          </p:stCondLst>
+                                        </p:cTn>
+                                        <p:tgtEl>
+                                          <p:spTgt spid="23">
+                                            <p:bg/>
+                                          </p:spTgt>
+                                        </p:tgtEl>
+                                        <p:attrNameLst>
+                                          <p:attrName>style.visibility</p:attrName>
+                                        </p:attrNameLst>
+                                      </p:cBhvr>
+                                      <p:to>
+                                        <p:strVal val="visible"/>
+                                      </p:to>
+                                    </p:set>
+                                    <p:animEffect transition="in" filter="fade">
+                                      <p:cBhvr>
+                                        <p:cTn id="18" dur="1000"/>
+                                        <p:tgtEl>
+                                          <p:spTgt spid="23">
+                                            <p:bg/>
+                                          </p:spTgt>
+                                        </p:tgtEl>
+                                      </p:cBhvr>
+                                    </p:animEffect>
+                                  </p:childTnLst>
+                                </p:cTn>
+                              </p:par>
+                              <p:par>
+                                <p:cTn id="19" presetID="10" presetClass="entr" presetSubtype="0" fill="hold" grpId="1" nodeType="withEffect">
+                                  <p:stCondLst>
+                                    <p:cond delay="0"/>
+                                  </p:stCondLst>
+                                  <p:childTnLst>
+                                    <p:set>
+                                      <p:cBhvr>
+                                        <p:cTn id="20" dur="1" fill="hold">
+                                          <p:stCondLst>
+                                            <p:cond delay="0"/>
+                                          </p:stCondLst>
+                                        </p:cTn>
+                                        <p:tgtEl>
+                                          <p:spTgt spid="23">
+                                            <p:txEl>
+                                              <p:pRg st="0" end="0"/>
+                                            </p:txEl>
+                                          </p:spTgt>
+                                        </p:tgtEl>
+                                        <p:attrNameLst>
+                                          <p:attrName>style.visibility</p:attrName>
+                                        </p:attrNameLst>
+                                      </p:cBhvr>
+                                      <p:to>
+                                        <p:strVal val="visible"/>
+                                      </p:to>
+                                    </p:set>
+                                    <p:animEffect transition="in" filter="fade">
+                                      <p:cBhvr>
+                                        <p:cTn id="21" dur="1000"/>
+                                        <p:tgtEl>
+                                          <p:spTgt spid="23">
+                                            <p:txEl>
+                                              <p:pRg st="0" end="0"/>
+                                            </p:txEl>
+                                          </p:spTgt>
                                         </p:tgtEl>
                                       </p:cBhvr>
                                     </p:animEffect>
@@ -8859,40 +9685,169 @@
                     </p:cTn>
                   </p:par>
                   <p:par>
-                    <p:cTn id="13" fill="hold">
+                    <p:cTn id="22" fill="hold">
                       <p:stCondLst>
                         <p:cond delay="indefinite"/>
                       </p:stCondLst>
                       <p:childTnLst>
                         <p:par>
-                          <p:cTn id="14" fill="hold">
+                          <p:cTn id="23" fill="hold">
                             <p:stCondLst>
                               <p:cond delay="0"/>
                             </p:stCondLst>
                             <p:childTnLst>
                               <p:par>
-                                <p:cTn id="15" presetID="10" presetClass="exit" presetSubtype="0" fill="hold" grpId="0" nodeType="clickEffect">
+                                <p:cTn id="24" presetID="10" presetClass="exit" presetSubtype="0" fill="hold" grpId="0" nodeType="clickEffect">
                                   <p:stCondLst>
                                     <p:cond delay="0"/>
                                   </p:stCondLst>
                                   <p:childTnLst>
                                     <p:animEffect transition="out" filter="fade">
                                       <p:cBhvr>
-                                        <p:cTn id="16" dur="500"/>
-                                        <p:tgtEl>
-                                          <p:spTgt spid="2"/>
+                                        <p:cTn id="25" dur="500"/>
+                                        <p:tgtEl>
+                                          <p:spTgt spid="2">
+                                            <p:txEl>
+                                              <p:pRg st="0" end="0"/>
+                                            </p:txEl>
+                                          </p:spTgt>
                                         </p:tgtEl>
                                       </p:cBhvr>
                                     </p:animEffect>
                                     <p:set>
                                       <p:cBhvr>
-                                        <p:cTn id="17" dur="1" fill="hold">
+                                        <p:cTn id="26" dur="1" fill="hold">
                                           <p:stCondLst>
                                             <p:cond delay="499"/>
                                           </p:stCondLst>
                                         </p:cTn>
                                         <p:tgtEl>
-                                          <p:spTgt spid="2"/>
+                                          <p:spTgt spid="2">
+                                            <p:txEl>
+                                              <p:pRg st="0" end="0"/>
+                                            </p:txEl>
+                                          </p:spTgt>
+                                        </p:tgtEl>
+                                        <p:attrNameLst>
+                                          <p:attrName>style.visibility</p:attrName>
+                                        </p:attrNameLst>
+                                      </p:cBhvr>
+                                      <p:to>
+                                        <p:strVal val="hidden"/>
+                                      </p:to>
+                                    </p:set>
+                                  </p:childTnLst>
+                                </p:cTn>
+                              </p:par>
+                              <p:par>
+                                <p:cTn id="27" presetID="10" presetClass="exit" presetSubtype="0" fill="hold" grpId="0" nodeType="withEffect">
+                                  <p:stCondLst>
+                                    <p:cond delay="0"/>
+                                  </p:stCondLst>
+                                  <p:childTnLst>
+                                    <p:animEffect transition="out" filter="fade">
+                                      <p:cBhvr>
+                                        <p:cTn id="28" dur="500"/>
+                                        <p:tgtEl>
+                                          <p:spTgt spid="2">
+                                            <p:bg/>
+                                          </p:spTgt>
+                                        </p:tgtEl>
+                                      </p:cBhvr>
+                                    </p:animEffect>
+                                    <p:set>
+                                      <p:cBhvr>
+                                        <p:cTn id="29" dur="1" fill="hold">
+                                          <p:stCondLst>
+                                            <p:cond delay="499"/>
+                                          </p:stCondLst>
+                                        </p:cTn>
+                                        <p:tgtEl>
+                                          <p:spTgt spid="2">
+                                            <p:bg/>
+                                          </p:spTgt>
+                                        </p:tgtEl>
+                                        <p:attrNameLst>
+                                          <p:attrName>style.visibility</p:attrName>
+                                        </p:attrNameLst>
+                                      </p:cBhvr>
+                                      <p:to>
+                                        <p:strVal val="hidden"/>
+                                      </p:to>
+                                    </p:set>
+                                  </p:childTnLst>
+                                </p:cTn>
+                              </p:par>
+                              <p:par>
+                                <p:cTn id="30" presetID="10" presetClass="exit" presetSubtype="0" fill="hold" grpId="0" nodeType="withEffect">
+                                  <p:stCondLst>
+                                    <p:cond delay="0"/>
+                                  </p:stCondLst>
+                                  <p:childTnLst>
+                                    <p:animEffect transition="out" filter="fade">
+                                      <p:cBhvr>
+                                        <p:cTn id="31" dur="500"/>
+                                        <p:tgtEl>
+                                          <p:spTgt spid="23">
+                                            <p:txEl>
+                                              <p:pRg st="0" end="0"/>
+                                            </p:txEl>
+                                          </p:spTgt>
+                                        </p:tgtEl>
+                                      </p:cBhvr>
+                                    </p:animEffect>
+                                    <p:set>
+                                      <p:cBhvr>
+                                        <p:cTn id="32" dur="1" fill="hold">
+                                          <p:stCondLst>
+                                            <p:cond delay="499"/>
+                                          </p:stCondLst>
+                                        </p:cTn>
+                                        <p:tgtEl>
+                                          <p:spTgt spid="23">
+                                            <p:txEl>
+                                              <p:pRg st="0" end="0"/>
+                                            </p:txEl>
+                                          </p:spTgt>
+                                        </p:tgtEl>
+                                        <p:attrNameLst>
+                                          <p:attrName>style.visibility</p:attrName>
+                                        </p:attrNameLst>
+                                      </p:cBhvr>
+                                      <p:to>
+                                        <p:strVal val="hidden"/>
+                                      </p:to>
+                                    </p:set>
+                                  </p:childTnLst>
+                                </p:cTn>
+                              </p:par>
+                              <p:par>
+                                <p:cTn id="33" presetID="10" presetClass="exit" presetSubtype="0" fill="hold" grpId="0" nodeType="withEffect">
+                                  <p:stCondLst>
+                                    <p:cond delay="0"/>
+                                  </p:stCondLst>
+                                  <p:childTnLst>
+                                    <p:animEffect transition="out" filter="fade">
+                                      <p:cBhvr>
+                                        <p:cTn id="34" dur="500"/>
+                                        <p:tgtEl>
+                                          <p:spTgt spid="23">
+                                            <p:bg/>
+                                          </p:spTgt>
+                                        </p:tgtEl>
+                                      </p:cBhvr>
+                                    </p:animEffect>
+                                    <p:set>
+                                      <p:cBhvr>
+                                        <p:cTn id="35" dur="1" fill="hold">
+                                          <p:stCondLst>
+                                            <p:cond delay="499"/>
+                                          </p:stCondLst>
+                                        </p:cTn>
+                                        <p:tgtEl>
+                                          <p:spTgt spid="23">
+                                            <p:bg/>
+                                          </p:spTgt>
                                         </p:tgtEl>
                                         <p:attrNameLst>
                                           <p:attrName>style.visibility</p:attrName>
@@ -8912,26 +9867,26 @@
                     </p:cTn>
                   </p:par>
                   <p:par>
-                    <p:cTn id="18" fill="hold">
+                    <p:cTn id="36" fill="hold">
                       <p:stCondLst>
                         <p:cond delay="indefinite"/>
                       </p:stCondLst>
                       <p:childTnLst>
                         <p:par>
-                          <p:cTn id="19" fill="hold">
+                          <p:cTn id="37" fill="hold">
                             <p:stCondLst>
                               <p:cond delay="0"/>
                             </p:stCondLst>
                             <p:childTnLst>
                               <p:par>
-                                <p:cTn id="20" presetID="10" presetClass="entr" presetSubtype="0" fill="hold" grpId="0" nodeType="clickEffect">
+                                <p:cTn id="38" presetID="10" presetClass="entr" presetSubtype="0" fill="hold" grpId="0" nodeType="clickEffect">
                                   <p:stCondLst>
                                     <p:cond delay="0"/>
                                   </p:stCondLst>
                                   <p:childTnLst>
                                     <p:set>
                                       <p:cBhvr>
-                                        <p:cTn id="21" dur="1" fill="hold">
+                                        <p:cTn id="39" dur="1" fill="hold">
                                           <p:stCondLst>
                                             <p:cond delay="0"/>
                                           </p:stCondLst>
@@ -8949,7 +9904,7 @@
                                     </p:set>
                                     <p:animEffect transition="in" filter="fade">
                                       <p:cBhvr>
-                                        <p:cTn id="22" dur="500"/>
+                                        <p:cTn id="40" dur="500"/>
                                         <p:tgtEl>
                                           <p:spTgt spid="8"/>
                                         </p:tgtEl>
@@ -8959,14 +9914,14 @@
                                 </p:cTn>
                               </p:par>
                               <p:par>
-                                <p:cTn id="23" presetID="10" presetClass="entr" presetSubtype="0" fill="hold" nodeType="withEffect">
+                                <p:cTn id="41" presetID="10" presetClass="entr" presetSubtype="0" fill="hold" nodeType="withEffect">
                                   <p:stCondLst>
                                     <p:cond delay="0"/>
                                   </p:stCondLst>
                                   <p:childTnLst>
                                     <p:set>
                                       <p:cBhvr>
-                                        <p:cTn id="24" dur="1" fill="hold">
+                                        <p:cTn id="42" dur="1" fill="hold">
                                           <p:stCondLst>
                                             <p:cond delay="0"/>
                                           </p:stCondLst>
@@ -8984,7 +9939,7 @@
                                     </p:set>
                                     <p:animEffect transition="in" filter="fade">
                                       <p:cBhvr>
-                                        <p:cTn id="25" dur="500"/>
+                                        <p:cTn id="43" dur="500"/>
                                         <p:tgtEl>
                                           <p:spTgt spid="7"/>
                                         </p:tgtEl>
@@ -8994,14 +9949,14 @@
                                 </p:cTn>
                               </p:par>
                               <p:par>
-                                <p:cTn id="26" presetID="1" presetClass="entr" presetSubtype="0" fill="hold" grpId="0" nodeType="withEffect">
+                                <p:cTn id="44" presetID="1" presetClass="entr" presetSubtype="0" fill="hold" grpId="0" nodeType="withEffect">
                                   <p:stCondLst>
                                     <p:cond delay="0"/>
                                   </p:stCondLst>
                                   <p:childTnLst>
                                     <p:set>
                                       <p:cBhvr>
-                                        <p:cTn id="27" dur="1" fill="hold">
+                                        <p:cTn id="45" dur="1" fill="hold">
                                           <p:stCondLst>
                                             <p:cond delay="0"/>
                                           </p:stCondLst>
@@ -9027,26 +9982,26 @@
                     </p:cTn>
                   </p:par>
                   <p:par>
-                    <p:cTn id="28" fill="hold">
+                    <p:cTn id="46" fill="hold">
                       <p:stCondLst>
                         <p:cond delay="indefinite"/>
                       </p:stCondLst>
                       <p:childTnLst>
                         <p:par>
-                          <p:cTn id="29" fill="hold">
+                          <p:cTn id="47" fill="hold">
                             <p:stCondLst>
                               <p:cond delay="0"/>
                             </p:stCondLst>
                             <p:childTnLst>
                               <p:par>
-                                <p:cTn id="30" presetID="10" presetClass="entr" presetSubtype="0" fill="hold" nodeType="clickEffect">
+                                <p:cTn id="48" presetID="10" presetClass="entr" presetSubtype="0" fill="hold" nodeType="clickEffect">
                                   <p:stCondLst>
                                     <p:cond delay="0"/>
                                   </p:stCondLst>
                                   <p:childTnLst>
                                     <p:set>
                                       <p:cBhvr>
-                                        <p:cTn id="31" dur="1" fill="hold">
+                                        <p:cTn id="49" dur="1" fill="hold">
                                           <p:stCondLst>
                                             <p:cond delay="0"/>
                                           </p:stCondLst>
@@ -9064,7 +10019,7 @@
                                     </p:set>
                                     <p:animEffect transition="in" filter="fade">
                                       <p:cBhvr>
-                                        <p:cTn id="32" dur="500"/>
+                                        <p:cTn id="50" dur="500"/>
                                         <p:tgtEl>
                                           <p:spTgt spid="21"/>
                                         </p:tgtEl>
@@ -9074,14 +10029,14 @@
                                 </p:cTn>
                               </p:par>
                               <p:par>
-                                <p:cTn id="33" presetID="10" presetClass="entr" presetSubtype="0" fill="hold" nodeType="withEffect">
+                                <p:cTn id="51" presetID="10" presetClass="entr" presetSubtype="0" fill="hold" nodeType="withEffect">
                                   <p:stCondLst>
                                     <p:cond delay="0"/>
                                   </p:stCondLst>
                                   <p:childTnLst>
                                     <p:set>
                                       <p:cBhvr>
-                                        <p:cTn id="34" dur="1" fill="hold">
+                                        <p:cTn id="52" dur="1" fill="hold">
                                           <p:stCondLst>
                                             <p:cond delay="0"/>
                                           </p:stCondLst>
@@ -9099,7 +10054,7 @@
                                     </p:set>
                                     <p:animEffect transition="in" filter="fade">
                                       <p:cBhvr>
-                                        <p:cTn id="35" dur="500"/>
+                                        <p:cTn id="53" dur="500"/>
                                         <p:tgtEl>
                                           <p:spTgt spid="13"/>
                                         </p:tgtEl>
@@ -9109,14 +10064,14 @@
                                 </p:cTn>
                               </p:par>
                               <p:par>
-                                <p:cTn id="36" presetID="10" presetClass="entr" presetSubtype="0" fill="hold" grpId="0" nodeType="withEffect">
+                                <p:cTn id="54" presetID="10" presetClass="entr" presetSubtype="0" fill="hold" grpId="0" nodeType="withEffect">
                                   <p:stCondLst>
                                     <p:cond delay="0"/>
                                   </p:stCondLst>
                                   <p:childTnLst>
                                     <p:set>
                                       <p:cBhvr>
-                                        <p:cTn id="37" dur="1" fill="hold">
+                                        <p:cTn id="55" dur="1" fill="hold">
                                           <p:stCondLst>
                                             <p:cond delay="0"/>
                                           </p:stCondLst>
@@ -9134,7 +10089,7 @@
                                     </p:set>
                                     <p:animEffect transition="in" filter="fade">
                                       <p:cBhvr>
-                                        <p:cTn id="38" dur="500"/>
+                                        <p:cTn id="56" dur="500"/>
                                         <p:tgtEl>
                                           <p:spTgt spid="20"/>
                                         </p:tgtEl>
@@ -9150,26 +10105,26 @@
                     </p:cTn>
                   </p:par>
                   <p:par>
-                    <p:cTn id="39" fill="hold">
+                    <p:cTn id="57" fill="hold">
                       <p:stCondLst>
                         <p:cond delay="indefinite"/>
                       </p:stCondLst>
                       <p:childTnLst>
                         <p:par>
-                          <p:cTn id="40" fill="hold">
+                          <p:cTn id="58" fill="hold">
                             <p:stCondLst>
                               <p:cond delay="0"/>
                             </p:stCondLst>
                             <p:childTnLst>
                               <p:par>
-                                <p:cTn id="41" presetID="10" presetClass="entr" presetSubtype="0" fill="hold" nodeType="clickEffect">
+                                <p:cTn id="59" presetID="10" presetClass="entr" presetSubtype="0" fill="hold" nodeType="clickEffect">
                                   <p:stCondLst>
                                     <p:cond delay="0"/>
                                   </p:stCondLst>
                                   <p:childTnLst>
                                     <p:set>
                                       <p:cBhvr>
-                                        <p:cTn id="42" dur="1" fill="hold">
+                                        <p:cTn id="60" dur="1" fill="hold">
                                           <p:stCondLst>
                                             <p:cond delay="0"/>
                                           </p:stCondLst>
@@ -9187,7 +10142,7 @@
                                     </p:set>
                                     <p:animEffect transition="in" filter="fade">
                                       <p:cBhvr>
-                                        <p:cTn id="43" dur="500"/>
+                                        <p:cTn id="61" dur="500"/>
                                         <p:tgtEl>
                                           <p:spTgt spid="17"/>
                                         </p:tgtEl>
@@ -9197,14 +10152,14 @@
                                 </p:cTn>
                               </p:par>
                               <p:par>
-                                <p:cTn id="44" presetID="10" presetClass="entr" presetSubtype="0" fill="hold" nodeType="withEffect">
+                                <p:cTn id="62" presetID="10" presetClass="entr" presetSubtype="0" fill="hold" nodeType="withEffect">
                                   <p:stCondLst>
                                     <p:cond delay="0"/>
                                   </p:stCondLst>
                                   <p:childTnLst>
                                     <p:set>
                                       <p:cBhvr>
-                                        <p:cTn id="45" dur="1" fill="hold">
+                                        <p:cTn id="63" dur="1" fill="hold">
                                           <p:stCondLst>
                                             <p:cond delay="0"/>
                                           </p:stCondLst>
@@ -9222,7 +10177,7 @@
                                     </p:set>
                                     <p:animEffect transition="in" filter="fade">
                                       <p:cBhvr>
-                                        <p:cTn id="46" dur="500"/>
+                                        <p:cTn id="64" dur="500"/>
                                         <p:tgtEl>
                                           <p:spTgt spid="14"/>
                                         </p:tgtEl>
@@ -9232,14 +10187,14 @@
                                 </p:cTn>
                               </p:par>
                               <p:par>
-                                <p:cTn id="47" presetID="10" presetClass="entr" presetSubtype="0" fill="hold" grpId="0" nodeType="withEffect">
+                                <p:cTn id="65" presetID="10" presetClass="entr" presetSubtype="0" fill="hold" grpId="0" nodeType="withEffect">
                                   <p:stCondLst>
                                     <p:cond delay="0"/>
                                   </p:stCondLst>
                                   <p:childTnLst>
                                     <p:set>
                                       <p:cBhvr>
-                                        <p:cTn id="48" dur="1" fill="hold">
+                                        <p:cTn id="66" dur="1" fill="hold">
                                           <p:stCondLst>
                                             <p:cond delay="0"/>
                                           </p:stCondLst>
@@ -9257,44 +10212,9 @@
                                     </p:set>
                                     <p:animEffect transition="in" filter="fade">
                                       <p:cBhvr>
-                                        <p:cTn id="49" dur="500"/>
+                                        <p:cTn id="67" dur="500"/>
                                         <p:tgtEl>
                                           <p:spTgt spid="19"/>
-                                        </p:tgtEl>
-                                      </p:cBhvr>
-                                    </p:animEffect>
-                                  </p:childTnLst>
-                                </p:cTn>
-                              </p:par>
-                              <p:par>
-                                <p:cTn id="50" presetID="22" presetClass="entr" presetSubtype="4" fill="hold" nodeType="withEffect">
-                                  <p:stCondLst>
-                                    <p:cond delay="200"/>
-                                  </p:stCondLst>
-                                  <p:childTnLst>
-                                    <p:set>
-                                      <p:cBhvr>
-                                        <p:cTn id="51" dur="1" fill="hold">
-                                          <p:stCondLst>
-                                            <p:cond delay="0"/>
-                                          </p:stCondLst>
-                                        </p:cTn>
-                                        <p:tgtEl>
-                                          <p:spTgt spid="25"/>
-                                        </p:tgtEl>
-                                        <p:attrNameLst>
-                                          <p:attrName>style.visibility</p:attrName>
-                                        </p:attrNameLst>
-                                      </p:cBhvr>
-                                      <p:to>
-                                        <p:strVal val="visible"/>
-                                      </p:to>
-                                    </p:set>
-                                    <p:animEffect transition="in" filter="wipe(down)">
-                                      <p:cBhvr>
-                                        <p:cTn id="52" dur="500"/>
-                                        <p:tgtEl>
-                                          <p:spTgt spid="25"/>
                                         </p:tgtEl>
                                       </p:cBhvr>
                                     </p:animEffect>
@@ -9308,32 +10228,32 @@
                     </p:cTn>
                   </p:par>
                   <p:par>
-                    <p:cTn id="53" fill="hold">
+                    <p:cTn id="68" fill="hold">
                       <p:stCondLst>
                         <p:cond delay="indefinite"/>
                       </p:stCondLst>
                       <p:childTnLst>
                         <p:par>
-                          <p:cTn id="54" fill="hold">
+                          <p:cTn id="69" fill="hold">
                             <p:stCondLst>
                               <p:cond delay="0"/>
                             </p:stCondLst>
                             <p:childTnLst>
                               <p:par>
-                                <p:cTn id="55" presetID="22" presetClass="entr" presetSubtype="1" fill="hold" nodeType="clickEffect">
+                                <p:cTn id="70" presetID="10" presetClass="entr" presetSubtype="0" fill="hold" grpId="0" nodeType="clickEffect">
                                   <p:stCondLst>
                                     <p:cond delay="0"/>
                                   </p:stCondLst>
                                   <p:childTnLst>
                                     <p:set>
                                       <p:cBhvr>
-                                        <p:cTn id="56" dur="1" fill="hold">
+                                        <p:cTn id="71" dur="1" fill="hold">
                                           <p:stCondLst>
                                             <p:cond delay="0"/>
                                           </p:stCondLst>
                                         </p:cTn>
                                         <p:tgtEl>
-                                          <p:spTgt spid="4"/>
+                                          <p:spTgt spid="26"/>
                                         </p:tgtEl>
                                         <p:attrNameLst>
                                           <p:attrName>style.visibility</p:attrName>
@@ -9343,81 +10263,11 @@
                                         <p:strVal val="visible"/>
                                       </p:to>
                                     </p:set>
-                                    <p:animEffect transition="in" filter="wipe(up)">
-                                      <p:cBhvr>
-                                        <p:cTn id="57" dur="500"/>
-                                        <p:tgtEl>
-                                          <p:spTgt spid="4"/>
-                                        </p:tgtEl>
-                                      </p:cBhvr>
-                                    </p:animEffect>
-                                  </p:childTnLst>
-                                </p:cTn>
-                              </p:par>
-                              <p:par>
-                                <p:cTn id="58" presetID="22" presetClass="entr" presetSubtype="4" fill="hold" grpId="0" nodeType="withEffect">
-                                  <p:stCondLst>
-                                    <p:cond delay="500"/>
-                                  </p:stCondLst>
-                                  <p:childTnLst>
-                                    <p:set>
-                                      <p:cBhvr>
-                                        <p:cTn id="59" dur="1" fill="hold">
-                                          <p:stCondLst>
-                                            <p:cond delay="0"/>
-                                          </p:stCondLst>
-                                        </p:cTn>
-                                        <p:tgtEl>
-                                          <p:spTgt spid="6"/>
-                                        </p:tgtEl>
-                                        <p:attrNameLst>
-                                          <p:attrName>style.visibility</p:attrName>
-                                        </p:attrNameLst>
-                                      </p:cBhvr>
-                                      <p:to>
-                                        <p:strVal val="visible"/>
-                                      </p:to>
-                                    </p:set>
-                                    <p:animEffect transition="in" filter="wipe(down)">
-                                      <p:cBhvr>
-                                        <p:cTn id="60" dur="500"/>
-                                        <p:tgtEl>
-                                          <p:spTgt spid="6"/>
-                                        </p:tgtEl>
-                                      </p:cBhvr>
-                                    </p:animEffect>
-                                  </p:childTnLst>
-                                </p:cTn>
-                              </p:par>
-                              <p:par>
-                                <p:cTn id="61" presetID="22" presetClass="entr" presetSubtype="1" fill="hold" nodeType="withEffect">
-                                  <p:stCondLst>
-                                    <p:cond delay="1000"/>
-                                  </p:stCondLst>
-                                  <p:childTnLst>
-                                    <p:set>
-                                      <p:cBhvr>
-                                        <p:cTn id="62" dur="1" fill="hold">
-                                          <p:stCondLst>
-                                            <p:cond delay="0"/>
-                                          </p:stCondLst>
-                                        </p:cTn>
-                                        <p:tgtEl>
-                                          <p:spTgt spid="16"/>
-                                        </p:tgtEl>
-                                        <p:attrNameLst>
-                                          <p:attrName>style.visibility</p:attrName>
-                                        </p:attrNameLst>
-                                      </p:cBhvr>
-                                      <p:to>
-                                        <p:strVal val="visible"/>
-                                      </p:to>
-                                    </p:set>
-                                    <p:animEffect transition="in" filter="wipe(up)">
-                                      <p:cBhvr>
-                                        <p:cTn id="63" dur="500"/>
-                                        <p:tgtEl>
-                                          <p:spTgt spid="16"/>
+                                    <p:animEffect transition="in" filter="fade">
+                                      <p:cBhvr>
+                                        <p:cTn id="72" dur="500"/>
+                                        <p:tgtEl>
+                                          <p:spTgt spid="26"/>
                                         </p:tgtEl>
                                       </p:cBhvr>
                                     </p:animEffect>
@@ -9431,40 +10281,40 @@
                     </p:cTn>
                   </p:par>
                   <p:par>
-                    <p:cTn id="64" fill="hold">
+                    <p:cTn id="73" fill="hold">
                       <p:stCondLst>
                         <p:cond delay="indefinite"/>
                       </p:stCondLst>
                       <p:childTnLst>
                         <p:par>
-                          <p:cTn id="65" fill="hold">
+                          <p:cTn id="74" fill="hold">
                             <p:stCondLst>
                               <p:cond delay="0"/>
                             </p:stCondLst>
                             <p:childTnLst>
                               <p:par>
-                                <p:cTn id="66" presetID="10" presetClass="exit" presetSubtype="0" fill="hold" grpId="1" nodeType="clickEffect">
+                                <p:cTn id="75" presetID="10" presetClass="exit" presetSubtype="0" fill="hold" grpId="1" nodeType="clickEffect">
                                   <p:stCondLst>
                                     <p:cond delay="0"/>
                                   </p:stCondLst>
                                   <p:childTnLst>
                                     <p:animEffect transition="out" filter="fade">
                                       <p:cBhvr>
-                                        <p:cTn id="67" dur="500"/>
-                                        <p:tgtEl>
-                                          <p:spTgt spid="6"/>
+                                        <p:cTn id="76" dur="500"/>
+                                        <p:tgtEl>
+                                          <p:spTgt spid="26"/>
                                         </p:tgtEl>
                                       </p:cBhvr>
                                     </p:animEffect>
                                     <p:set>
                                       <p:cBhvr>
-                                        <p:cTn id="68" dur="1" fill="hold">
+                                        <p:cTn id="77" dur="1" fill="hold">
                                           <p:stCondLst>
                                             <p:cond delay="499"/>
                                           </p:stCondLst>
                                         </p:cTn>
                                         <p:tgtEl>
-                                          <p:spTgt spid="6"/>
+                                          <p:spTgt spid="26"/>
                                         </p:tgtEl>
                                         <p:attrNameLst>
                                           <p:attrName>style.visibility</p:attrName>
@@ -9477,29 +10327,408 @@
                                   </p:childTnLst>
                                 </p:cTn>
                               </p:par>
+                            </p:childTnLst>
+                          </p:cTn>
+                        </p:par>
+                        <p:par>
+                          <p:cTn id="78" fill="hold">
+                            <p:stCondLst>
+                              <p:cond delay="500"/>
+                            </p:stCondLst>
+                            <p:childTnLst>
                               <p:par>
-                                <p:cTn id="69" presetID="10" presetClass="exit" presetSubtype="0" fill="hold" nodeType="withEffect">
+                                <p:cTn id="79" presetID="22" presetClass="entr" presetSubtype="4" fill="hold" nodeType="afterEffect">
+                                  <p:stCondLst>
+                                    <p:cond delay="0"/>
+                                  </p:stCondLst>
+                                  <p:childTnLst>
+                                    <p:set>
+                                      <p:cBhvr>
+                                        <p:cTn id="80" dur="1" fill="hold">
+                                          <p:stCondLst>
+                                            <p:cond delay="0"/>
+                                          </p:stCondLst>
+                                        </p:cTn>
+                                        <p:tgtEl>
+                                          <p:spTgt spid="25"/>
+                                        </p:tgtEl>
+                                        <p:attrNameLst>
+                                          <p:attrName>style.visibility</p:attrName>
+                                        </p:attrNameLst>
+                                      </p:cBhvr>
+                                      <p:to>
+                                        <p:strVal val="visible"/>
+                                      </p:to>
+                                    </p:set>
+                                    <p:animEffect transition="in" filter="wipe(down)">
+                                      <p:cBhvr>
+                                        <p:cTn id="81" dur="500"/>
+                                        <p:tgtEl>
+                                          <p:spTgt spid="25"/>
+                                        </p:tgtEl>
+                                      </p:cBhvr>
+                                    </p:animEffect>
+                                  </p:childTnLst>
+                                </p:cTn>
+                              </p:par>
+                            </p:childTnLst>
+                          </p:cTn>
+                        </p:par>
+                      </p:childTnLst>
+                    </p:cTn>
+                  </p:par>
+                  <p:par>
+                    <p:cTn id="82" fill="hold">
+                      <p:stCondLst>
+                        <p:cond delay="indefinite"/>
+                      </p:stCondLst>
+                      <p:childTnLst>
+                        <p:par>
+                          <p:cTn id="83" fill="hold">
+                            <p:stCondLst>
+                              <p:cond delay="0"/>
+                            </p:stCondLst>
+                            <p:childTnLst>
+                              <p:par>
+                                <p:cTn id="84" presetID="22" presetClass="entr" presetSubtype="1" fill="hold" nodeType="clickEffect">
+                                  <p:stCondLst>
+                                    <p:cond delay="0"/>
+                                  </p:stCondLst>
+                                  <p:childTnLst>
+                                    <p:set>
+                                      <p:cBhvr>
+                                        <p:cTn id="85" dur="1" fill="hold">
+                                          <p:stCondLst>
+                                            <p:cond delay="0"/>
+                                          </p:stCondLst>
+                                        </p:cTn>
+                                        <p:tgtEl>
+                                          <p:spTgt spid="4"/>
+                                        </p:tgtEl>
+                                        <p:attrNameLst>
+                                          <p:attrName>style.visibility</p:attrName>
+                                        </p:attrNameLst>
+                                      </p:cBhvr>
+                                      <p:to>
+                                        <p:strVal val="visible"/>
+                                      </p:to>
+                                    </p:set>
+                                    <p:animEffect transition="in" filter="wipe(up)">
+                                      <p:cBhvr>
+                                        <p:cTn id="86" dur="500"/>
+                                        <p:tgtEl>
+                                          <p:spTgt spid="4"/>
+                                        </p:tgtEl>
+                                      </p:cBhvr>
+                                    </p:animEffect>
+                                  </p:childTnLst>
+                                </p:cTn>
+                              </p:par>
+                              <p:par>
+                                <p:cTn id="87" presetID="22" presetClass="entr" presetSubtype="4" fill="hold" grpId="0" nodeType="withEffect">
+                                  <p:stCondLst>
+                                    <p:cond delay="500"/>
+                                  </p:stCondLst>
+                                  <p:childTnLst>
+                                    <p:set>
+                                      <p:cBhvr>
+                                        <p:cTn id="88" dur="1" fill="hold">
+                                          <p:stCondLst>
+                                            <p:cond delay="0"/>
+                                          </p:stCondLst>
+                                        </p:cTn>
+                                        <p:tgtEl>
+                                          <p:spTgt spid="6"/>
+                                        </p:tgtEl>
+                                        <p:attrNameLst>
+                                          <p:attrName>style.visibility</p:attrName>
+                                        </p:attrNameLst>
+                                      </p:cBhvr>
+                                      <p:to>
+                                        <p:strVal val="visible"/>
+                                      </p:to>
+                                    </p:set>
+                                    <p:animEffect transition="in" filter="wipe(down)">
+                                      <p:cBhvr>
+                                        <p:cTn id="89" dur="500"/>
+                                        <p:tgtEl>
+                                          <p:spTgt spid="6"/>
+                                        </p:tgtEl>
+                                      </p:cBhvr>
+                                    </p:animEffect>
+                                  </p:childTnLst>
+                                </p:cTn>
+                              </p:par>
+                              <p:par>
+                                <p:cTn id="90" presetID="22" presetClass="entr" presetSubtype="4" fill="hold" nodeType="withEffect">
+                                  <p:stCondLst>
+                                    <p:cond delay="1000"/>
+                                  </p:stCondLst>
+                                  <p:childTnLst>
+                                    <p:set>
+                                      <p:cBhvr>
+                                        <p:cTn id="91" dur="1" fill="hold">
+                                          <p:stCondLst>
+                                            <p:cond delay="0"/>
+                                          </p:stCondLst>
+                                        </p:cTn>
+                                        <p:tgtEl>
+                                          <p:spTgt spid="16"/>
+                                        </p:tgtEl>
+                                        <p:attrNameLst>
+                                          <p:attrName>style.visibility</p:attrName>
+                                        </p:attrNameLst>
+                                      </p:cBhvr>
+                                      <p:to>
+                                        <p:strVal val="visible"/>
+                                      </p:to>
+                                    </p:set>
+                                    <p:animEffect transition="in" filter="wipe(down)">
+                                      <p:cBhvr>
+                                        <p:cTn id="92" dur="500"/>
+                                        <p:tgtEl>
+                                          <p:spTgt spid="16"/>
+                                        </p:tgtEl>
+                                      </p:cBhvr>
+                                    </p:animEffect>
+                                  </p:childTnLst>
+                                </p:cTn>
+                              </p:par>
+                            </p:childTnLst>
+                          </p:cTn>
+                        </p:par>
+                      </p:childTnLst>
+                    </p:cTn>
+                  </p:par>
+                  <p:par>
+                    <p:cTn id="93" fill="hold">
+                      <p:stCondLst>
+                        <p:cond delay="indefinite"/>
+                      </p:stCondLst>
+                      <p:childTnLst>
+                        <p:par>
+                          <p:cTn id="94" fill="hold">
+                            <p:stCondLst>
+                              <p:cond delay="0"/>
+                            </p:stCondLst>
+                            <p:childTnLst>
+                              <p:par>
+                                <p:cTn id="95" presetID="22" presetClass="entr" presetSubtype="8" fill="hold" nodeType="clickEffect">
+                                  <p:stCondLst>
+                                    <p:cond delay="0"/>
+                                  </p:stCondLst>
+                                  <p:childTnLst>
+                                    <p:set>
+                                      <p:cBhvr>
+                                        <p:cTn id="96" dur="1" fill="hold">
+                                          <p:stCondLst>
+                                            <p:cond delay="0"/>
+                                          </p:stCondLst>
+                                        </p:cTn>
+                                        <p:tgtEl>
+                                          <p:spTgt spid="9"/>
+                                        </p:tgtEl>
+                                        <p:attrNameLst>
+                                          <p:attrName>style.visibility</p:attrName>
+                                        </p:attrNameLst>
+                                      </p:cBhvr>
+                                      <p:to>
+                                        <p:strVal val="visible"/>
+                                      </p:to>
+                                    </p:set>
+                                    <p:animEffect transition="in" filter="wipe(left)">
+                                      <p:cBhvr>
+                                        <p:cTn id="97" dur="500"/>
+                                        <p:tgtEl>
+                                          <p:spTgt spid="9"/>
+                                        </p:tgtEl>
+                                      </p:cBhvr>
+                                    </p:animEffect>
+                                  </p:childTnLst>
+                                </p:cTn>
+                              </p:par>
+                              <p:par>
+                                <p:cTn id="98" presetID="10" presetClass="entr" presetSubtype="0" fill="hold" grpId="0" nodeType="withEffect">
+                                  <p:stCondLst>
+                                    <p:cond delay="500"/>
+                                  </p:stCondLst>
+                                  <p:childTnLst>
+                                    <p:set>
+                                      <p:cBhvr>
+                                        <p:cTn id="99" dur="1" fill="hold">
+                                          <p:stCondLst>
+                                            <p:cond delay="0"/>
+                                          </p:stCondLst>
+                                        </p:cTn>
+                                        <p:tgtEl>
+                                          <p:spTgt spid="12"/>
+                                        </p:tgtEl>
+                                        <p:attrNameLst>
+                                          <p:attrName>style.visibility</p:attrName>
+                                        </p:attrNameLst>
+                                      </p:cBhvr>
+                                      <p:to>
+                                        <p:strVal val="visible"/>
+                                      </p:to>
+                                    </p:set>
+                                    <p:animEffect transition="in" filter="fade">
+                                      <p:cBhvr>
+                                        <p:cTn id="100" dur="500"/>
+                                        <p:tgtEl>
+                                          <p:spTgt spid="12"/>
+                                        </p:tgtEl>
+                                      </p:cBhvr>
+                                    </p:animEffect>
+                                  </p:childTnLst>
+                                </p:cTn>
+                              </p:par>
+                            </p:childTnLst>
+                          </p:cTn>
+                        </p:par>
+                      </p:childTnLst>
+                    </p:cTn>
+                  </p:par>
+                  <p:par>
+                    <p:cTn id="101" fill="hold">
+                      <p:stCondLst>
+                        <p:cond delay="indefinite"/>
+                      </p:stCondLst>
+                      <p:childTnLst>
+                        <p:par>
+                          <p:cTn id="102" fill="hold">
+                            <p:stCondLst>
+                              <p:cond delay="0"/>
+                            </p:stCondLst>
+                            <p:childTnLst>
+                              <p:par>
+                                <p:cTn id="103" presetID="10" presetClass="entr" presetSubtype="0" fill="hold" nodeType="clickEffect">
+                                  <p:stCondLst>
+                                    <p:cond delay="0"/>
+                                  </p:stCondLst>
+                                  <p:childTnLst>
+                                    <p:set>
+                                      <p:cBhvr>
+                                        <p:cTn id="104" dur="1" fill="hold">
+                                          <p:stCondLst>
+                                            <p:cond delay="0"/>
+                                          </p:stCondLst>
+                                        </p:cTn>
+                                        <p:tgtEl>
+                                          <p:spTgt spid="15"/>
+                                        </p:tgtEl>
+                                        <p:attrNameLst>
+                                          <p:attrName>style.visibility</p:attrName>
+                                        </p:attrNameLst>
+                                      </p:cBhvr>
+                                      <p:to>
+                                        <p:strVal val="visible"/>
+                                      </p:to>
+                                    </p:set>
+                                    <p:animEffect transition="in" filter="fade">
+                                      <p:cBhvr>
+                                        <p:cTn id="105" dur="500"/>
+                                        <p:tgtEl>
+                                          <p:spTgt spid="15"/>
+                                        </p:tgtEl>
+                                      </p:cBhvr>
+                                    </p:animEffect>
+                                  </p:childTnLst>
+                                </p:cTn>
+                              </p:par>
+                            </p:childTnLst>
+                          </p:cTn>
+                        </p:par>
+                      </p:childTnLst>
+                    </p:cTn>
+                  </p:par>
+                  <p:par>
+                    <p:cTn id="106" fill="hold">
+                      <p:stCondLst>
+                        <p:cond delay="indefinite"/>
+                      </p:stCondLst>
+                      <p:childTnLst>
+                        <p:par>
+                          <p:cTn id="107" fill="hold">
+                            <p:stCondLst>
+                              <p:cond delay="0"/>
+                            </p:stCondLst>
+                            <p:childTnLst>
+                              <p:par>
+                                <p:cTn id="108" presetID="10" presetClass="entr" presetSubtype="0" fill="hold" grpId="0" nodeType="clickEffect">
+                                  <p:stCondLst>
+                                    <p:cond delay="0"/>
+                                  </p:stCondLst>
+                                  <p:childTnLst>
+                                    <p:set>
+                                      <p:cBhvr>
+                                        <p:cTn id="109" dur="1" fill="hold">
+                                          <p:stCondLst>
+                                            <p:cond delay="0"/>
+                                          </p:stCondLst>
+                                        </p:cTn>
+                                        <p:tgtEl>
+                                          <p:spTgt spid="24"/>
+                                        </p:tgtEl>
+                                        <p:attrNameLst>
+                                          <p:attrName>style.visibility</p:attrName>
+                                        </p:attrNameLst>
+                                      </p:cBhvr>
+                                      <p:to>
+                                        <p:strVal val="visible"/>
+                                      </p:to>
+                                    </p:set>
+                                    <p:animEffect transition="in" filter="fade">
+                                      <p:cBhvr>
+                                        <p:cTn id="110" dur="500"/>
+                                        <p:tgtEl>
+                                          <p:spTgt spid="24"/>
+                                        </p:tgtEl>
+                                      </p:cBhvr>
+                                    </p:animEffect>
+                                  </p:childTnLst>
+                                </p:cTn>
+                              </p:par>
+                            </p:childTnLst>
+                          </p:cTn>
+                        </p:par>
+                      </p:childTnLst>
+                    </p:cTn>
+                  </p:par>
+                  <p:par>
+                    <p:cTn id="111" fill="hold">
+                      <p:stCondLst>
+                        <p:cond delay="indefinite"/>
+                      </p:stCondLst>
+                      <p:childTnLst>
+                        <p:par>
+                          <p:cTn id="112" fill="hold">
+                            <p:stCondLst>
+                              <p:cond delay="0"/>
+                            </p:stCondLst>
+                            <p:childTnLst>
+                              <p:par>
+                                <p:cTn id="113" presetID="10" presetClass="exit" presetSubtype="0" fill="hold" grpId="1" nodeType="clickEffect">
                                   <p:stCondLst>
                                     <p:cond delay="0"/>
                                   </p:stCondLst>
                                   <p:childTnLst>
                                     <p:animEffect transition="out" filter="fade">
                                       <p:cBhvr>
-                                        <p:cTn id="70" dur="500"/>
-                                        <p:tgtEl>
-                                          <p:spTgt spid="4"/>
+                                        <p:cTn id="114" dur="500"/>
+                                        <p:tgtEl>
+                                          <p:spTgt spid="24"/>
                                         </p:tgtEl>
                                       </p:cBhvr>
                                     </p:animEffect>
                                     <p:set>
                                       <p:cBhvr>
-                                        <p:cTn id="71" dur="1" fill="hold">
+                                        <p:cTn id="115" dur="1" fill="hold">
                                           <p:stCondLst>
                                             <p:cond delay="499"/>
                                           </p:stCondLst>
                                         </p:cTn>
                                         <p:tgtEl>
-                                          <p:spTgt spid="4"/>
+                                          <p:spTgt spid="24"/>
                                         </p:tgtEl>
                                         <p:attrNameLst>
                                           <p:attrName>style.visibility</p:attrName>
@@ -9512,38 +10741,103 @@
                                   </p:childTnLst>
                                 </p:cTn>
                               </p:par>
+                            </p:childTnLst>
+                          </p:cTn>
+                        </p:par>
+                      </p:childTnLst>
+                    </p:cTn>
+                  </p:par>
+                  <p:par>
+                    <p:cTn id="116" fill="hold">
+                      <p:stCondLst>
+                        <p:cond delay="indefinite"/>
+                      </p:stCondLst>
+                      <p:childTnLst>
+                        <p:par>
+                          <p:cTn id="117" fill="hold">
+                            <p:stCondLst>
+                              <p:cond delay="0"/>
+                            </p:stCondLst>
+                            <p:childTnLst>
                               <p:par>
-                                <p:cTn id="72" presetID="10" presetClass="exit" presetSubtype="0" fill="hold" nodeType="withEffect">
+                                <p:cTn id="118" presetID="10" presetClass="entr" presetSubtype="0" fill="hold" grpId="1" nodeType="clickEffect">
                                   <p:stCondLst>
                                     <p:cond delay="0"/>
                                   </p:stCondLst>
                                   <p:childTnLst>
-                                    <p:animEffect transition="out" filter="fade">
-                                      <p:cBhvr>
-                                        <p:cTn id="73" dur="500"/>
-                                        <p:tgtEl>
-                                          <p:spTgt spid="16"/>
-                                        </p:tgtEl>
-                                      </p:cBhvr>
-                                    </p:animEffect>
                                     <p:set>
                                       <p:cBhvr>
-                                        <p:cTn id="74" dur="1" fill="hold">
+                                        <p:cTn id="119" dur="1" fill="hold">
                                           <p:stCondLst>
-                                            <p:cond delay="499"/>
+                                            <p:cond delay="0"/>
                                           </p:stCondLst>
                                         </p:cTn>
                                         <p:tgtEl>
-                                          <p:spTgt spid="16"/>
+                                          <p:spTgt spid="10">
+                                            <p:bg/>
+                                          </p:spTgt>
                                         </p:tgtEl>
                                         <p:attrNameLst>
                                           <p:attrName>style.visibility</p:attrName>
                                         </p:attrNameLst>
                                       </p:cBhvr>
                                       <p:to>
-                                        <p:strVal val="hidden"/>
+                                        <p:strVal val="visible"/>
                                       </p:to>
                                     </p:set>
+                                    <p:animEffect transition="in" filter="fade">
+                                      <p:cBhvr>
+                                        <p:cTn id="120" dur="1000"/>
+                                        <p:tgtEl>
+                                          <p:spTgt spid="10">
+                                            <p:bg/>
+                                          </p:spTgt>
+                                        </p:tgtEl>
+                                      </p:cBhvr>
+                                    </p:animEffect>
+                                  </p:childTnLst>
+                                </p:cTn>
+                              </p:par>
+                              <p:par>
+                                <p:cTn id="121" presetID="10" presetClass="entr" presetSubtype="0" fill="hold" grpId="1" nodeType="withEffect">
+                                  <p:stCondLst>
+                                    <p:cond delay="0"/>
+                                  </p:stCondLst>
+                                  <p:childTnLst>
+                                    <p:set>
+                                      <p:cBhvr>
+                                        <p:cTn id="122" dur="1" fill="hold">
+                                          <p:stCondLst>
+                                            <p:cond delay="0"/>
+                                          </p:stCondLst>
+                                        </p:cTn>
+                                        <p:tgtEl>
+                                          <p:spTgt spid="10">
+                                            <p:txEl>
+                                              <p:pRg st="0" end="0"/>
+                                            </p:txEl>
+                                          </p:spTgt>
+                                        </p:tgtEl>
+                                        <p:attrNameLst>
+                                          <p:attrName>style.visibility</p:attrName>
+                                        </p:attrNameLst>
+                                      </p:cBhvr>
+                                      <p:to>
+                                        <p:strVal val="visible"/>
+                                      </p:to>
+                                    </p:set>
+                                    <p:animEffect transition="in" filter="fade">
+                                      <p:cBhvr>
+                                        <p:cTn id="123" dur="1000"/>
+                                        <p:tgtEl>
+                                          <p:spTgt spid="10">
+                                            <p:txEl>
+                                              <p:pRg st="0" end="0"/>
+                                            </p:txEl>
+                                          </p:spTgt>
+                                        </p:tgtEl>
+                                      </p:cBhvr>
+                                    </p:animEffect>
                                   </p:childTnLst>
                                 </p:cTn>
                               </p:par>
@@ -9577,12 +10871,19 @@
     <p:bldLst>
       <p:bldP spid="8" grpId="0" animBg="1"/>
       <p:bldP spid="19" grpId="0" animBg="1"/>
-      <p:bldP spid="2" grpId="0" animBg="1"/>
-      <p:bldP spid="2" grpId="1" animBg="1"/>
+      <p:bldP spid="2" grpId="0" uiExpand="1" build="allAtOnce" animBg="1"/>
+      <p:bldP spid="2" grpId="1" build="allAtOnce" animBg="1" rev="1"/>
       <p:bldP spid="3" grpId="0"/>
       <p:bldP spid="6" grpId="0" animBg="1"/>
-      <p:bldP spid="6" grpId="1" animBg="1"/>
       <p:bldP spid="20" grpId="0" animBg="1"/>
+      <p:bldP spid="12" grpId="0" animBg="1"/>
+      <p:bldP spid="23" grpId="0" build="allAtOnce" animBg="1"/>
+      <p:bldP spid="23" grpId="1" build="allAtOnce" animBg="1" rev="1"/>
+      <p:bldP spid="24" grpId="0" animBg="1"/>
+      <p:bldP spid="24" grpId="1" animBg="1"/>
+      <p:bldP spid="26" grpId="0" animBg="1"/>
+      <p:bldP spid="26" grpId="1" animBg="1"/>
+      <p:bldP spid="10" grpId="1" uiExpand="1" build="allAtOnce" animBg="1" rev="1"/>
     </p:bldLst>
   </p:timing>
 </p:sld>
@@ -9644,6 +10945,175 @@
     <p:extLst>
       <p:ext uri="{BB962C8B-B14F-4D97-AF65-F5344CB8AC3E}">
         <p14:creationId xmlns:p14="http://schemas.microsoft.com/office/powerpoint/2010/main" val="1493236109"/>
+      </p:ext>
+    </p:extLst>
+  </p:cSld>
+  <p:clrMapOvr>
+    <a:masterClrMapping/>
+  </p:clrMapOvr>
+</p:sld>
+</file>
+
+<file path=ppt/slides/slide7.xml><?xml version="1.0" encoding="utf-8"?>
+<p:sld xmlns:a="http://schemas.openxmlformats.org/drawingml/2006/main" xmlns:r="http://schemas.openxmlformats.org/officeDocument/2006/relationships" xmlns:p="http://schemas.openxmlformats.org/presentationml/2006/main">
+  <p:cSld>
+    <p:spTree>
+      <p:nvGrpSpPr>
+        <p:cNvPr id="1" name=""/>
+        <p:cNvGrpSpPr/>
+        <p:nvPr/>
+      </p:nvGrpSpPr>
+      <p:grpSpPr>
+        <a:xfrm>
+          <a:off x="0" y="0"/>
+          <a:ext cx="0" cy="0"/>
+          <a:chOff x="0" y="0"/>
+          <a:chExt cx="0" cy="0"/>
+        </a:xfrm>
+      </p:grpSpPr>
+      <p:sp>
+        <p:nvSpPr>
+          <p:cNvPr id="2" name="Title 1">
+            <a:extLst>
+              <a:ext uri="{FF2B5EF4-FFF2-40B4-BE49-F238E27FC236}">
+                <a16:creationId xmlns:a16="http://schemas.microsoft.com/office/drawing/2014/main" id="{A73A3C44-B071-1818-A129-716F930F957A}"/>
+              </a:ext>
+            </a:extLst>
+          </p:cNvPr>
+          <p:cNvSpPr>
+            <a:spLocks noGrp="1"/>
+          </p:cNvSpPr>
+          <p:nvPr>
+            <p:ph type="title"/>
+          </p:nvPr>
+        </p:nvSpPr>
+        <p:spPr/>
+        <p:txBody>
+          <a:bodyPr/>
+          <a:lstStyle/>
+          <a:p>
+            <a:r>
+              <a:rPr lang="en-GB" dirty="0"/>
+              <a:t>Tech spec used</a:t>
+            </a:r>
+          </a:p>
+        </p:txBody>
+      </p:sp>
+      <p:sp>
+        <p:nvSpPr>
+          <p:cNvPr id="3" name="Content Placeholder 2">
+            <a:extLst>
+              <a:ext uri="{FF2B5EF4-FFF2-40B4-BE49-F238E27FC236}">
+                <a16:creationId xmlns:a16="http://schemas.microsoft.com/office/drawing/2014/main" id="{F36E8297-D3C0-B8C4-7AD8-58ECA31A1D8C}"/>
+              </a:ext>
+            </a:extLst>
+          </p:cNvPr>
+          <p:cNvSpPr>
+            <a:spLocks noGrp="1"/>
+          </p:cNvSpPr>
+          <p:nvPr>
+            <p:ph idx="1"/>
+          </p:nvPr>
+        </p:nvSpPr>
+        <p:spPr/>
+        <p:txBody>
+          <a:bodyPr>
+            <a:normAutofit fontScale="85000" lnSpcReduction="20000"/>
+          </a:bodyPr>
+          <a:lstStyle/>
+          <a:p>
+            <a:r>
+              <a:rPr lang="en-GB" dirty="0"/>
+              <a:t>IDEs</a:t>
+            </a:r>
+          </a:p>
+          <a:p>
+            <a:pPr lvl="1"/>
+            <a:r>
+              <a:rPr lang="en-GB" dirty="0"/>
+              <a:t>VS code</a:t>
+            </a:r>
+          </a:p>
+          <a:p>
+            <a:pPr lvl="1"/>
+            <a:r>
+              <a:rPr lang="en-GB" dirty="0"/>
+              <a:t>Visual Studio</a:t>
+            </a:r>
+          </a:p>
+          <a:p>
+            <a:r>
+              <a:rPr lang="en-GB" dirty="0"/>
+              <a:t>Containerization of microservices</a:t>
+            </a:r>
+          </a:p>
+          <a:p>
+            <a:pPr lvl="1"/>
+            <a:r>
+              <a:rPr lang="en-GB" dirty="0"/>
+              <a:t>Docker containers (Docker desktop (on Windows))</a:t>
+            </a:r>
+          </a:p>
+          <a:p>
+            <a:pPr lvl="1"/>
+            <a:r>
+              <a:rPr lang="en-GB" dirty="0"/>
+              <a:t>RabbitMQ</a:t>
+            </a:r>
+          </a:p>
+          <a:p>
+            <a:pPr lvl="1"/>
+            <a:r>
+              <a:rPr lang="en-GB" dirty="0"/>
+              <a:t>Azurite (Blob Storage Solution)</a:t>
+            </a:r>
+          </a:p>
+          <a:p>
+            <a:r>
+              <a:rPr lang="en-GB" dirty="0"/>
+              <a:t>Blob Explorer</a:t>
+            </a:r>
+          </a:p>
+          <a:p>
+            <a:pPr lvl="1"/>
+            <a:r>
+              <a:rPr lang="en-GB" dirty="0"/>
+              <a:t>Microsoft Azure Storage Explorer</a:t>
+            </a:r>
+          </a:p>
+          <a:p>
+            <a:r>
+              <a:rPr lang="en-GB" dirty="0"/>
+              <a:t>AI tools used</a:t>
+            </a:r>
+          </a:p>
+          <a:p>
+            <a:pPr lvl="1"/>
+            <a:r>
+              <a:rPr lang="en-GB" dirty="0"/>
+              <a:t>ChatGPT online</a:t>
+            </a:r>
+          </a:p>
+          <a:p>
+            <a:pPr lvl="1"/>
+            <a:r>
+              <a:rPr lang="en-GB" dirty="0"/>
+              <a:t>Claude Code</a:t>
+            </a:r>
+          </a:p>
+          <a:p>
+            <a:pPr lvl="1"/>
+            <a:r>
+              <a:rPr lang="en-GB" dirty="0"/>
+              <a:t>GitHub Copilot in VS code</a:t>
+            </a:r>
+          </a:p>
+        </p:txBody>
+      </p:sp>
+    </p:spTree>
+    <p:extLst>
+      <p:ext uri="{BB962C8B-B14F-4D97-AF65-F5344CB8AC3E}">
+        <p14:creationId xmlns:p14="http://schemas.microsoft.com/office/powerpoint/2010/main" val="1555701955"/>
       </p:ext>
     </p:extLst>
   </p:cSld>

</xml_diff>

<commit_message>
Updated slides to match the current development progress.
</commit_message>
<xml_diff>
--- a/docs/DocFlow Workflow.pptx
+++ b/docs/DocFlow Workflow.pptx
@@ -12,6 +12,9 @@
     <p:sldId id="259" r:id="rId6"/>
     <p:sldId id="258" r:id="rId7"/>
     <p:sldId id="263" r:id="rId8"/>
+    <p:sldId id="266" r:id="rId9"/>
+    <p:sldId id="264" r:id="rId10"/>
+    <p:sldId id="265" r:id="rId11"/>
   </p:sldIdLst>
   <p:sldSz cx="12192000" cy="6858000"/>
   <p:notesSz cx="6858000" cy="9144000"/>
@@ -267,7 +270,7 @@
           <a:p>
             <a:fld id="{C6E6855C-4451-4D51-9C19-AA57B9F05DC3}" type="datetimeFigureOut">
               <a:rPr lang="en-GB" smtClean="0"/>
-              <a:t>05/06/2026</a:t>
+              <a:t>15/06/2026</a:t>
             </a:fld>
             <a:endParaRPr lang="en-GB"/>
           </a:p>
@@ -467,7 +470,7 @@
           <a:p>
             <a:fld id="{C6E6855C-4451-4D51-9C19-AA57B9F05DC3}" type="datetimeFigureOut">
               <a:rPr lang="en-GB" smtClean="0"/>
-              <a:t>05/06/2026</a:t>
+              <a:t>15/06/2026</a:t>
             </a:fld>
             <a:endParaRPr lang="en-GB"/>
           </a:p>
@@ -677,7 +680,7 @@
           <a:p>
             <a:fld id="{C6E6855C-4451-4D51-9C19-AA57B9F05DC3}" type="datetimeFigureOut">
               <a:rPr lang="en-GB" smtClean="0"/>
-              <a:t>05/06/2026</a:t>
+              <a:t>15/06/2026</a:t>
             </a:fld>
             <a:endParaRPr lang="en-GB"/>
           </a:p>
@@ -877,7 +880,7 @@
           <a:p>
             <a:fld id="{C6E6855C-4451-4D51-9C19-AA57B9F05DC3}" type="datetimeFigureOut">
               <a:rPr lang="en-GB" smtClean="0"/>
-              <a:t>05/06/2026</a:t>
+              <a:t>15/06/2026</a:t>
             </a:fld>
             <a:endParaRPr lang="en-GB"/>
           </a:p>
@@ -1153,7 +1156,7 @@
           <a:p>
             <a:fld id="{C6E6855C-4451-4D51-9C19-AA57B9F05DC3}" type="datetimeFigureOut">
               <a:rPr lang="en-GB" smtClean="0"/>
-              <a:t>05/06/2026</a:t>
+              <a:t>15/06/2026</a:t>
             </a:fld>
             <a:endParaRPr lang="en-GB"/>
           </a:p>
@@ -1421,7 +1424,7 @@
           <a:p>
             <a:fld id="{C6E6855C-4451-4D51-9C19-AA57B9F05DC3}" type="datetimeFigureOut">
               <a:rPr lang="en-GB" smtClean="0"/>
-              <a:t>05/06/2026</a:t>
+              <a:t>15/06/2026</a:t>
             </a:fld>
             <a:endParaRPr lang="en-GB"/>
           </a:p>
@@ -1836,7 +1839,7 @@
           <a:p>
             <a:fld id="{C6E6855C-4451-4D51-9C19-AA57B9F05DC3}" type="datetimeFigureOut">
               <a:rPr lang="en-GB" smtClean="0"/>
-              <a:t>05/06/2026</a:t>
+              <a:t>15/06/2026</a:t>
             </a:fld>
             <a:endParaRPr lang="en-GB"/>
           </a:p>
@@ -1978,7 +1981,7 @@
           <a:p>
             <a:fld id="{C6E6855C-4451-4D51-9C19-AA57B9F05DC3}" type="datetimeFigureOut">
               <a:rPr lang="en-GB" smtClean="0"/>
-              <a:t>05/06/2026</a:t>
+              <a:t>15/06/2026</a:t>
             </a:fld>
             <a:endParaRPr lang="en-GB"/>
           </a:p>
@@ -2091,7 +2094,7 @@
           <a:p>
             <a:fld id="{C6E6855C-4451-4D51-9C19-AA57B9F05DC3}" type="datetimeFigureOut">
               <a:rPr lang="en-GB" smtClean="0"/>
-              <a:t>05/06/2026</a:t>
+              <a:t>15/06/2026</a:t>
             </a:fld>
             <a:endParaRPr lang="en-GB"/>
           </a:p>
@@ -2404,7 +2407,7 @@
           <a:p>
             <a:fld id="{C6E6855C-4451-4D51-9C19-AA57B9F05DC3}" type="datetimeFigureOut">
               <a:rPr lang="en-GB" smtClean="0"/>
-              <a:t>05/06/2026</a:t>
+              <a:t>15/06/2026</a:t>
             </a:fld>
             <a:endParaRPr lang="en-GB"/>
           </a:p>
@@ -2693,7 +2696,7 @@
           <a:p>
             <a:fld id="{C6E6855C-4451-4D51-9C19-AA57B9F05DC3}" type="datetimeFigureOut">
               <a:rPr lang="en-GB" smtClean="0"/>
-              <a:t>05/06/2026</a:t>
+              <a:t>15/06/2026</a:t>
             </a:fld>
             <a:endParaRPr lang="en-GB"/>
           </a:p>
@@ -2936,7 +2939,7 @@
           <a:p>
             <a:fld id="{C6E6855C-4451-4D51-9C19-AA57B9F05DC3}" type="datetimeFigureOut">
               <a:rPr lang="en-GB" smtClean="0"/>
-              <a:t>05/06/2026</a:t>
+              <a:t>15/06/2026</a:t>
             </a:fld>
             <a:endParaRPr lang="en-GB"/>
           </a:p>
@@ -3422,6 +3425,89 @@
 </p:sld>
 </file>
 
+<file path=ppt/slides/slide10.xml><?xml version="1.0" encoding="utf-8"?>
+<p:sld xmlns:a="http://schemas.openxmlformats.org/drawingml/2006/main" xmlns:r="http://schemas.openxmlformats.org/officeDocument/2006/relationships" xmlns:p="http://schemas.openxmlformats.org/presentationml/2006/main">
+  <p:cSld>
+    <p:spTree>
+      <p:nvGrpSpPr>
+        <p:cNvPr id="1" name=""/>
+        <p:cNvGrpSpPr/>
+        <p:nvPr/>
+      </p:nvGrpSpPr>
+      <p:grpSpPr>
+        <a:xfrm>
+          <a:off x="0" y="0"/>
+          <a:ext cx="0" cy="0"/>
+          <a:chOff x="0" y="0"/>
+          <a:chExt cx="0" cy="0"/>
+        </a:xfrm>
+      </p:grpSpPr>
+      <p:sp>
+        <p:nvSpPr>
+          <p:cNvPr id="2" name="Title 1">
+            <a:extLst>
+              <a:ext uri="{FF2B5EF4-FFF2-40B4-BE49-F238E27FC236}">
+                <a16:creationId xmlns:a16="http://schemas.microsoft.com/office/drawing/2014/main" id="{1BA92B70-9E43-C098-7EAA-03AE874335B2}"/>
+              </a:ext>
+            </a:extLst>
+          </p:cNvPr>
+          <p:cNvSpPr>
+            <a:spLocks noGrp="1"/>
+          </p:cNvSpPr>
+          <p:nvPr>
+            <p:ph type="title"/>
+          </p:nvPr>
+        </p:nvSpPr>
+        <p:spPr/>
+        <p:txBody>
+          <a:bodyPr/>
+          <a:lstStyle/>
+          <a:p>
+            <a:r>
+              <a:rPr lang="en-GB" dirty="0"/>
+              <a:t>Live environment (Azure)</a:t>
+            </a:r>
+          </a:p>
+        </p:txBody>
+      </p:sp>
+      <p:sp>
+        <p:nvSpPr>
+          <p:cNvPr id="3" name="Content Placeholder 2">
+            <a:extLst>
+              <a:ext uri="{FF2B5EF4-FFF2-40B4-BE49-F238E27FC236}">
+                <a16:creationId xmlns:a16="http://schemas.microsoft.com/office/drawing/2014/main" id="{19595AEA-D98D-C7D5-1DEA-2988114F2408}"/>
+              </a:ext>
+            </a:extLst>
+          </p:cNvPr>
+          <p:cNvSpPr>
+            <a:spLocks noGrp="1"/>
+          </p:cNvSpPr>
+          <p:nvPr>
+            <p:ph idx="1"/>
+          </p:nvPr>
+        </p:nvSpPr>
+        <p:spPr/>
+        <p:txBody>
+          <a:bodyPr/>
+          <a:lstStyle/>
+          <a:p>
+            <a:endParaRPr lang="en-GB"/>
+          </a:p>
+        </p:txBody>
+      </p:sp>
+    </p:spTree>
+    <p:extLst>
+      <p:ext uri="{BB962C8B-B14F-4D97-AF65-F5344CB8AC3E}">
+        <p14:creationId xmlns:p14="http://schemas.microsoft.com/office/powerpoint/2010/main" val="1574109059"/>
+      </p:ext>
+    </p:extLst>
+  </p:cSld>
+  <p:clrMapOvr>
+    <a:masterClrMapping/>
+  </p:clrMapOvr>
+</p:sld>
+</file>
+
 <file path=ppt/slides/slide2.xml><?xml version="1.0" encoding="utf-8"?>
 <p:sld xmlns:a="http://schemas.openxmlformats.org/drawingml/2006/main" xmlns:r="http://schemas.openxmlformats.org/officeDocument/2006/relationships" xmlns:p="http://schemas.openxmlformats.org/presentationml/2006/main">
   <p:cSld>
@@ -11114,6 +11200,874 @@
     <p:extLst>
       <p:ext uri="{BB962C8B-B14F-4D97-AF65-F5344CB8AC3E}">
         <p14:creationId xmlns:p14="http://schemas.microsoft.com/office/powerpoint/2010/main" val="1555701955"/>
+      </p:ext>
+    </p:extLst>
+  </p:cSld>
+  <p:clrMapOvr>
+    <a:masterClrMapping/>
+  </p:clrMapOvr>
+  <p:timing>
+    <p:tnLst>
+      <p:par>
+        <p:cTn id="1" dur="indefinite" restart="never" nodeType="tmRoot">
+          <p:childTnLst>
+            <p:seq concurrent="1" nextAc="seek">
+              <p:cTn id="2" dur="indefinite" nodeType="mainSeq">
+                <p:childTnLst>
+                  <p:par>
+                    <p:cTn id="3" fill="hold">
+                      <p:stCondLst>
+                        <p:cond delay="indefinite"/>
+                      </p:stCondLst>
+                      <p:childTnLst>
+                        <p:par>
+                          <p:cTn id="4" fill="hold">
+                            <p:stCondLst>
+                              <p:cond delay="0"/>
+                            </p:stCondLst>
+                            <p:childTnLst>
+                              <p:par>
+                                <p:cTn id="5" presetID="10" presetClass="entr" presetSubtype="0" fill="hold" nodeType="clickEffect">
+                                  <p:stCondLst>
+                                    <p:cond delay="0"/>
+                                  </p:stCondLst>
+                                  <p:childTnLst>
+                                    <p:set>
+                                      <p:cBhvr>
+                                        <p:cTn id="6" dur="1" fill="hold">
+                                          <p:stCondLst>
+                                            <p:cond delay="0"/>
+                                          </p:stCondLst>
+                                        </p:cTn>
+                                        <p:tgtEl>
+                                          <p:spTgt spid="3">
+                                            <p:txEl>
+                                              <p:pRg st="0" end="0"/>
+                                            </p:txEl>
+                                          </p:spTgt>
+                                        </p:tgtEl>
+                                        <p:attrNameLst>
+                                          <p:attrName>style.visibility</p:attrName>
+                                        </p:attrNameLst>
+                                      </p:cBhvr>
+                                      <p:to>
+                                        <p:strVal val="visible"/>
+                                      </p:to>
+                                    </p:set>
+                                    <p:animEffect transition="in" filter="fade">
+                                      <p:cBhvr>
+                                        <p:cTn id="7" dur="500"/>
+                                        <p:tgtEl>
+                                          <p:spTgt spid="3">
+                                            <p:txEl>
+                                              <p:pRg st="0" end="0"/>
+                                            </p:txEl>
+                                          </p:spTgt>
+                                        </p:tgtEl>
+                                      </p:cBhvr>
+                                    </p:animEffect>
+                                  </p:childTnLst>
+                                </p:cTn>
+                              </p:par>
+                              <p:par>
+                                <p:cTn id="8" presetID="10" presetClass="entr" presetSubtype="0" fill="hold" nodeType="withEffect">
+                                  <p:stCondLst>
+                                    <p:cond delay="0"/>
+                                  </p:stCondLst>
+                                  <p:childTnLst>
+                                    <p:set>
+                                      <p:cBhvr>
+                                        <p:cTn id="9" dur="1" fill="hold">
+                                          <p:stCondLst>
+                                            <p:cond delay="0"/>
+                                          </p:stCondLst>
+                                        </p:cTn>
+                                        <p:tgtEl>
+                                          <p:spTgt spid="3">
+                                            <p:txEl>
+                                              <p:pRg st="1" end="1"/>
+                                            </p:txEl>
+                                          </p:spTgt>
+                                        </p:tgtEl>
+                                        <p:attrNameLst>
+                                          <p:attrName>style.visibility</p:attrName>
+                                        </p:attrNameLst>
+                                      </p:cBhvr>
+                                      <p:to>
+                                        <p:strVal val="visible"/>
+                                      </p:to>
+                                    </p:set>
+                                    <p:animEffect transition="in" filter="fade">
+                                      <p:cBhvr>
+                                        <p:cTn id="10" dur="500"/>
+                                        <p:tgtEl>
+                                          <p:spTgt spid="3">
+                                            <p:txEl>
+                                              <p:pRg st="1" end="1"/>
+                                            </p:txEl>
+                                          </p:spTgt>
+                                        </p:tgtEl>
+                                      </p:cBhvr>
+                                    </p:animEffect>
+                                  </p:childTnLst>
+                                </p:cTn>
+                              </p:par>
+                              <p:par>
+                                <p:cTn id="11" presetID="10" presetClass="entr" presetSubtype="0" fill="hold" nodeType="withEffect">
+                                  <p:stCondLst>
+                                    <p:cond delay="0"/>
+                                  </p:stCondLst>
+                                  <p:childTnLst>
+                                    <p:set>
+                                      <p:cBhvr>
+                                        <p:cTn id="12" dur="1" fill="hold">
+                                          <p:stCondLst>
+                                            <p:cond delay="0"/>
+                                          </p:stCondLst>
+                                        </p:cTn>
+                                        <p:tgtEl>
+                                          <p:spTgt spid="3">
+                                            <p:txEl>
+                                              <p:pRg st="2" end="2"/>
+                                            </p:txEl>
+                                          </p:spTgt>
+                                        </p:tgtEl>
+                                        <p:attrNameLst>
+                                          <p:attrName>style.visibility</p:attrName>
+                                        </p:attrNameLst>
+                                      </p:cBhvr>
+                                      <p:to>
+                                        <p:strVal val="visible"/>
+                                      </p:to>
+                                    </p:set>
+                                    <p:animEffect transition="in" filter="fade">
+                                      <p:cBhvr>
+                                        <p:cTn id="13" dur="500"/>
+                                        <p:tgtEl>
+                                          <p:spTgt spid="3">
+                                            <p:txEl>
+                                              <p:pRg st="2" end="2"/>
+                                            </p:txEl>
+                                          </p:spTgt>
+                                        </p:tgtEl>
+                                      </p:cBhvr>
+                                    </p:animEffect>
+                                  </p:childTnLst>
+                                </p:cTn>
+                              </p:par>
+                            </p:childTnLst>
+                          </p:cTn>
+                        </p:par>
+                      </p:childTnLst>
+                    </p:cTn>
+                  </p:par>
+                  <p:par>
+                    <p:cTn id="14" fill="hold">
+                      <p:stCondLst>
+                        <p:cond delay="indefinite"/>
+                      </p:stCondLst>
+                      <p:childTnLst>
+                        <p:par>
+                          <p:cTn id="15" fill="hold">
+                            <p:stCondLst>
+                              <p:cond delay="0"/>
+                            </p:stCondLst>
+                            <p:childTnLst>
+                              <p:par>
+                                <p:cTn id="16" presetID="10" presetClass="entr" presetSubtype="0" fill="hold" nodeType="clickEffect">
+                                  <p:stCondLst>
+                                    <p:cond delay="0"/>
+                                  </p:stCondLst>
+                                  <p:childTnLst>
+                                    <p:set>
+                                      <p:cBhvr>
+                                        <p:cTn id="17" dur="1" fill="hold">
+                                          <p:stCondLst>
+                                            <p:cond delay="0"/>
+                                          </p:stCondLst>
+                                        </p:cTn>
+                                        <p:tgtEl>
+                                          <p:spTgt spid="3">
+                                            <p:txEl>
+                                              <p:pRg st="3" end="3"/>
+                                            </p:txEl>
+                                          </p:spTgt>
+                                        </p:tgtEl>
+                                        <p:attrNameLst>
+                                          <p:attrName>style.visibility</p:attrName>
+                                        </p:attrNameLst>
+                                      </p:cBhvr>
+                                      <p:to>
+                                        <p:strVal val="visible"/>
+                                      </p:to>
+                                    </p:set>
+                                    <p:animEffect transition="in" filter="fade">
+                                      <p:cBhvr>
+                                        <p:cTn id="18" dur="500"/>
+                                        <p:tgtEl>
+                                          <p:spTgt spid="3">
+                                            <p:txEl>
+                                              <p:pRg st="3" end="3"/>
+                                            </p:txEl>
+                                          </p:spTgt>
+                                        </p:tgtEl>
+                                      </p:cBhvr>
+                                    </p:animEffect>
+                                  </p:childTnLst>
+                                </p:cTn>
+                              </p:par>
+                              <p:par>
+                                <p:cTn id="19" presetID="10" presetClass="entr" presetSubtype="0" fill="hold" nodeType="withEffect">
+                                  <p:stCondLst>
+                                    <p:cond delay="0"/>
+                                  </p:stCondLst>
+                                  <p:childTnLst>
+                                    <p:set>
+                                      <p:cBhvr>
+                                        <p:cTn id="20" dur="1" fill="hold">
+                                          <p:stCondLst>
+                                            <p:cond delay="0"/>
+                                          </p:stCondLst>
+                                        </p:cTn>
+                                        <p:tgtEl>
+                                          <p:spTgt spid="3">
+                                            <p:txEl>
+                                              <p:pRg st="4" end="4"/>
+                                            </p:txEl>
+                                          </p:spTgt>
+                                        </p:tgtEl>
+                                        <p:attrNameLst>
+                                          <p:attrName>style.visibility</p:attrName>
+                                        </p:attrNameLst>
+                                      </p:cBhvr>
+                                      <p:to>
+                                        <p:strVal val="visible"/>
+                                      </p:to>
+                                    </p:set>
+                                    <p:animEffect transition="in" filter="fade">
+                                      <p:cBhvr>
+                                        <p:cTn id="21" dur="500"/>
+                                        <p:tgtEl>
+                                          <p:spTgt spid="3">
+                                            <p:txEl>
+                                              <p:pRg st="4" end="4"/>
+                                            </p:txEl>
+                                          </p:spTgt>
+                                        </p:tgtEl>
+                                      </p:cBhvr>
+                                    </p:animEffect>
+                                  </p:childTnLst>
+                                </p:cTn>
+                              </p:par>
+                              <p:par>
+                                <p:cTn id="22" presetID="10" presetClass="entr" presetSubtype="0" fill="hold" nodeType="withEffect">
+                                  <p:stCondLst>
+                                    <p:cond delay="0"/>
+                                  </p:stCondLst>
+                                  <p:childTnLst>
+                                    <p:set>
+                                      <p:cBhvr>
+                                        <p:cTn id="23" dur="1" fill="hold">
+                                          <p:stCondLst>
+                                            <p:cond delay="0"/>
+                                          </p:stCondLst>
+                                        </p:cTn>
+                                        <p:tgtEl>
+                                          <p:spTgt spid="3">
+                                            <p:txEl>
+                                              <p:pRg st="5" end="5"/>
+                                            </p:txEl>
+                                          </p:spTgt>
+                                        </p:tgtEl>
+                                        <p:attrNameLst>
+                                          <p:attrName>style.visibility</p:attrName>
+                                        </p:attrNameLst>
+                                      </p:cBhvr>
+                                      <p:to>
+                                        <p:strVal val="visible"/>
+                                      </p:to>
+                                    </p:set>
+                                    <p:animEffect transition="in" filter="fade">
+                                      <p:cBhvr>
+                                        <p:cTn id="24" dur="500"/>
+                                        <p:tgtEl>
+                                          <p:spTgt spid="3">
+                                            <p:txEl>
+                                              <p:pRg st="5" end="5"/>
+                                            </p:txEl>
+                                          </p:spTgt>
+                                        </p:tgtEl>
+                                      </p:cBhvr>
+                                    </p:animEffect>
+                                  </p:childTnLst>
+                                </p:cTn>
+                              </p:par>
+                              <p:par>
+                                <p:cTn id="25" presetID="10" presetClass="entr" presetSubtype="0" fill="hold" nodeType="withEffect">
+                                  <p:stCondLst>
+                                    <p:cond delay="0"/>
+                                  </p:stCondLst>
+                                  <p:childTnLst>
+                                    <p:set>
+                                      <p:cBhvr>
+                                        <p:cTn id="26" dur="1" fill="hold">
+                                          <p:stCondLst>
+                                            <p:cond delay="0"/>
+                                          </p:stCondLst>
+                                        </p:cTn>
+                                        <p:tgtEl>
+                                          <p:spTgt spid="3">
+                                            <p:txEl>
+                                              <p:pRg st="6" end="6"/>
+                                            </p:txEl>
+                                          </p:spTgt>
+                                        </p:tgtEl>
+                                        <p:attrNameLst>
+                                          <p:attrName>style.visibility</p:attrName>
+                                        </p:attrNameLst>
+                                      </p:cBhvr>
+                                      <p:to>
+                                        <p:strVal val="visible"/>
+                                      </p:to>
+                                    </p:set>
+                                    <p:animEffect transition="in" filter="fade">
+                                      <p:cBhvr>
+                                        <p:cTn id="27" dur="500"/>
+                                        <p:tgtEl>
+                                          <p:spTgt spid="3">
+                                            <p:txEl>
+                                              <p:pRg st="6" end="6"/>
+                                            </p:txEl>
+                                          </p:spTgt>
+                                        </p:tgtEl>
+                                      </p:cBhvr>
+                                    </p:animEffect>
+                                  </p:childTnLst>
+                                </p:cTn>
+                              </p:par>
+                            </p:childTnLst>
+                          </p:cTn>
+                        </p:par>
+                      </p:childTnLst>
+                    </p:cTn>
+                  </p:par>
+                  <p:par>
+                    <p:cTn id="28" fill="hold">
+                      <p:stCondLst>
+                        <p:cond delay="indefinite"/>
+                      </p:stCondLst>
+                      <p:childTnLst>
+                        <p:par>
+                          <p:cTn id="29" fill="hold">
+                            <p:stCondLst>
+                              <p:cond delay="0"/>
+                            </p:stCondLst>
+                            <p:childTnLst>
+                              <p:par>
+                                <p:cTn id="30" presetID="10" presetClass="entr" presetSubtype="0" fill="hold" nodeType="clickEffect">
+                                  <p:stCondLst>
+                                    <p:cond delay="0"/>
+                                  </p:stCondLst>
+                                  <p:childTnLst>
+                                    <p:set>
+                                      <p:cBhvr>
+                                        <p:cTn id="31" dur="1" fill="hold">
+                                          <p:stCondLst>
+                                            <p:cond delay="0"/>
+                                          </p:stCondLst>
+                                        </p:cTn>
+                                        <p:tgtEl>
+                                          <p:spTgt spid="3">
+                                            <p:txEl>
+                                              <p:pRg st="7" end="7"/>
+                                            </p:txEl>
+                                          </p:spTgt>
+                                        </p:tgtEl>
+                                        <p:attrNameLst>
+                                          <p:attrName>style.visibility</p:attrName>
+                                        </p:attrNameLst>
+                                      </p:cBhvr>
+                                      <p:to>
+                                        <p:strVal val="visible"/>
+                                      </p:to>
+                                    </p:set>
+                                    <p:animEffect transition="in" filter="fade">
+                                      <p:cBhvr>
+                                        <p:cTn id="32" dur="500"/>
+                                        <p:tgtEl>
+                                          <p:spTgt spid="3">
+                                            <p:txEl>
+                                              <p:pRg st="7" end="7"/>
+                                            </p:txEl>
+                                          </p:spTgt>
+                                        </p:tgtEl>
+                                      </p:cBhvr>
+                                    </p:animEffect>
+                                  </p:childTnLst>
+                                </p:cTn>
+                              </p:par>
+                              <p:par>
+                                <p:cTn id="33" presetID="10" presetClass="entr" presetSubtype="0" fill="hold" nodeType="withEffect">
+                                  <p:stCondLst>
+                                    <p:cond delay="0"/>
+                                  </p:stCondLst>
+                                  <p:childTnLst>
+                                    <p:set>
+                                      <p:cBhvr>
+                                        <p:cTn id="34" dur="1" fill="hold">
+                                          <p:stCondLst>
+                                            <p:cond delay="0"/>
+                                          </p:stCondLst>
+                                        </p:cTn>
+                                        <p:tgtEl>
+                                          <p:spTgt spid="3">
+                                            <p:txEl>
+                                              <p:pRg st="8" end="8"/>
+                                            </p:txEl>
+                                          </p:spTgt>
+                                        </p:tgtEl>
+                                        <p:attrNameLst>
+                                          <p:attrName>style.visibility</p:attrName>
+                                        </p:attrNameLst>
+                                      </p:cBhvr>
+                                      <p:to>
+                                        <p:strVal val="visible"/>
+                                      </p:to>
+                                    </p:set>
+                                    <p:animEffect transition="in" filter="fade">
+                                      <p:cBhvr>
+                                        <p:cTn id="35" dur="500"/>
+                                        <p:tgtEl>
+                                          <p:spTgt spid="3">
+                                            <p:txEl>
+                                              <p:pRg st="8" end="8"/>
+                                            </p:txEl>
+                                          </p:spTgt>
+                                        </p:tgtEl>
+                                      </p:cBhvr>
+                                    </p:animEffect>
+                                  </p:childTnLst>
+                                </p:cTn>
+                              </p:par>
+                            </p:childTnLst>
+                          </p:cTn>
+                        </p:par>
+                      </p:childTnLst>
+                    </p:cTn>
+                  </p:par>
+                  <p:par>
+                    <p:cTn id="36" fill="hold">
+                      <p:stCondLst>
+                        <p:cond delay="indefinite"/>
+                      </p:stCondLst>
+                      <p:childTnLst>
+                        <p:par>
+                          <p:cTn id="37" fill="hold">
+                            <p:stCondLst>
+                              <p:cond delay="0"/>
+                            </p:stCondLst>
+                            <p:childTnLst>
+                              <p:par>
+                                <p:cTn id="38" presetID="10" presetClass="entr" presetSubtype="0" fill="hold" nodeType="clickEffect">
+                                  <p:stCondLst>
+                                    <p:cond delay="0"/>
+                                  </p:stCondLst>
+                                  <p:childTnLst>
+                                    <p:set>
+                                      <p:cBhvr>
+                                        <p:cTn id="39" dur="1" fill="hold">
+                                          <p:stCondLst>
+                                            <p:cond delay="0"/>
+                                          </p:stCondLst>
+                                        </p:cTn>
+                                        <p:tgtEl>
+                                          <p:spTgt spid="3">
+                                            <p:txEl>
+                                              <p:pRg st="9" end="9"/>
+                                            </p:txEl>
+                                          </p:spTgt>
+                                        </p:tgtEl>
+                                        <p:attrNameLst>
+                                          <p:attrName>style.visibility</p:attrName>
+                                        </p:attrNameLst>
+                                      </p:cBhvr>
+                                      <p:to>
+                                        <p:strVal val="visible"/>
+                                      </p:to>
+                                    </p:set>
+                                    <p:animEffect transition="in" filter="fade">
+                                      <p:cBhvr>
+                                        <p:cTn id="40" dur="500"/>
+                                        <p:tgtEl>
+                                          <p:spTgt spid="3">
+                                            <p:txEl>
+                                              <p:pRg st="9" end="9"/>
+                                            </p:txEl>
+                                          </p:spTgt>
+                                        </p:tgtEl>
+                                      </p:cBhvr>
+                                    </p:animEffect>
+                                  </p:childTnLst>
+                                </p:cTn>
+                              </p:par>
+                              <p:par>
+                                <p:cTn id="41" presetID="10" presetClass="entr" presetSubtype="0" fill="hold" nodeType="withEffect">
+                                  <p:stCondLst>
+                                    <p:cond delay="0"/>
+                                  </p:stCondLst>
+                                  <p:childTnLst>
+                                    <p:set>
+                                      <p:cBhvr>
+                                        <p:cTn id="42" dur="1" fill="hold">
+                                          <p:stCondLst>
+                                            <p:cond delay="0"/>
+                                          </p:stCondLst>
+                                        </p:cTn>
+                                        <p:tgtEl>
+                                          <p:spTgt spid="3">
+                                            <p:txEl>
+                                              <p:pRg st="10" end="10"/>
+                                            </p:txEl>
+                                          </p:spTgt>
+                                        </p:tgtEl>
+                                        <p:attrNameLst>
+                                          <p:attrName>style.visibility</p:attrName>
+                                        </p:attrNameLst>
+                                      </p:cBhvr>
+                                      <p:to>
+                                        <p:strVal val="visible"/>
+                                      </p:to>
+                                    </p:set>
+                                    <p:animEffect transition="in" filter="fade">
+                                      <p:cBhvr>
+                                        <p:cTn id="43" dur="500"/>
+                                        <p:tgtEl>
+                                          <p:spTgt spid="3">
+                                            <p:txEl>
+                                              <p:pRg st="10" end="10"/>
+                                            </p:txEl>
+                                          </p:spTgt>
+                                        </p:tgtEl>
+                                      </p:cBhvr>
+                                    </p:animEffect>
+                                  </p:childTnLst>
+                                </p:cTn>
+                              </p:par>
+                              <p:par>
+                                <p:cTn id="44" presetID="10" presetClass="entr" presetSubtype="0" fill="hold" nodeType="withEffect">
+                                  <p:stCondLst>
+                                    <p:cond delay="0"/>
+                                  </p:stCondLst>
+                                  <p:childTnLst>
+                                    <p:set>
+                                      <p:cBhvr>
+                                        <p:cTn id="45" dur="1" fill="hold">
+                                          <p:stCondLst>
+                                            <p:cond delay="0"/>
+                                          </p:stCondLst>
+                                        </p:cTn>
+                                        <p:tgtEl>
+                                          <p:spTgt spid="3">
+                                            <p:txEl>
+                                              <p:pRg st="11" end="11"/>
+                                            </p:txEl>
+                                          </p:spTgt>
+                                        </p:tgtEl>
+                                        <p:attrNameLst>
+                                          <p:attrName>style.visibility</p:attrName>
+                                        </p:attrNameLst>
+                                      </p:cBhvr>
+                                      <p:to>
+                                        <p:strVal val="visible"/>
+                                      </p:to>
+                                    </p:set>
+                                    <p:animEffect transition="in" filter="fade">
+                                      <p:cBhvr>
+                                        <p:cTn id="46" dur="500"/>
+                                        <p:tgtEl>
+                                          <p:spTgt spid="3">
+                                            <p:txEl>
+                                              <p:pRg st="11" end="11"/>
+                                            </p:txEl>
+                                          </p:spTgt>
+                                        </p:tgtEl>
+                                      </p:cBhvr>
+                                    </p:animEffect>
+                                  </p:childTnLst>
+                                </p:cTn>
+                              </p:par>
+                              <p:par>
+                                <p:cTn id="47" presetID="10" presetClass="entr" presetSubtype="0" fill="hold" nodeType="withEffect">
+                                  <p:stCondLst>
+                                    <p:cond delay="0"/>
+                                  </p:stCondLst>
+                                  <p:childTnLst>
+                                    <p:set>
+                                      <p:cBhvr>
+                                        <p:cTn id="48" dur="1" fill="hold">
+                                          <p:stCondLst>
+                                            <p:cond delay="0"/>
+                                          </p:stCondLst>
+                                        </p:cTn>
+                                        <p:tgtEl>
+                                          <p:spTgt spid="3">
+                                            <p:txEl>
+                                              <p:pRg st="12" end="12"/>
+                                            </p:txEl>
+                                          </p:spTgt>
+                                        </p:tgtEl>
+                                        <p:attrNameLst>
+                                          <p:attrName>style.visibility</p:attrName>
+                                        </p:attrNameLst>
+                                      </p:cBhvr>
+                                      <p:to>
+                                        <p:strVal val="visible"/>
+                                      </p:to>
+                                    </p:set>
+                                    <p:animEffect transition="in" filter="fade">
+                                      <p:cBhvr>
+                                        <p:cTn id="49" dur="500"/>
+                                        <p:tgtEl>
+                                          <p:spTgt spid="3">
+                                            <p:txEl>
+                                              <p:pRg st="12" end="12"/>
+                                            </p:txEl>
+                                          </p:spTgt>
+                                        </p:tgtEl>
+                                      </p:cBhvr>
+                                    </p:animEffect>
+                                  </p:childTnLst>
+                                </p:cTn>
+                              </p:par>
+                            </p:childTnLst>
+                          </p:cTn>
+                        </p:par>
+                      </p:childTnLst>
+                    </p:cTn>
+                  </p:par>
+                </p:childTnLst>
+              </p:cTn>
+              <p:prevCondLst>
+                <p:cond evt="onPrev" delay="0">
+                  <p:tgtEl>
+                    <p:sldTgt/>
+                  </p:tgtEl>
+                </p:cond>
+              </p:prevCondLst>
+              <p:nextCondLst>
+                <p:cond evt="onNext" delay="0">
+                  <p:tgtEl>
+                    <p:sldTgt/>
+                  </p:tgtEl>
+                </p:cond>
+              </p:nextCondLst>
+            </p:seq>
+          </p:childTnLst>
+        </p:cTn>
+      </p:par>
+    </p:tnLst>
+  </p:timing>
+</p:sld>
+</file>
+
+<file path=ppt/slides/slide8.xml><?xml version="1.0" encoding="utf-8"?>
+<p:sld xmlns:a="http://schemas.openxmlformats.org/drawingml/2006/main" xmlns:r="http://schemas.openxmlformats.org/officeDocument/2006/relationships" xmlns:p="http://schemas.openxmlformats.org/presentationml/2006/main">
+  <p:cSld>
+    <p:spTree>
+      <p:nvGrpSpPr>
+        <p:cNvPr id="1" name=""/>
+        <p:cNvGrpSpPr/>
+        <p:nvPr/>
+      </p:nvGrpSpPr>
+      <p:grpSpPr>
+        <a:xfrm>
+          <a:off x="0" y="0"/>
+          <a:ext cx="0" cy="0"/>
+          <a:chOff x="0" y="0"/>
+          <a:chExt cx="0" cy="0"/>
+        </a:xfrm>
+      </p:grpSpPr>
+      <p:sp>
+        <p:nvSpPr>
+          <p:cNvPr id="2" name="Title 1">
+            <a:extLst>
+              <a:ext uri="{FF2B5EF4-FFF2-40B4-BE49-F238E27FC236}">
+                <a16:creationId xmlns:a16="http://schemas.microsoft.com/office/drawing/2014/main" id="{1F6C24E7-B615-57DB-2DF0-123361EFCF78}"/>
+              </a:ext>
+            </a:extLst>
+          </p:cNvPr>
+          <p:cNvSpPr>
+            <a:spLocks noGrp="1"/>
+          </p:cNvSpPr>
+          <p:nvPr>
+            <p:ph type="title"/>
+          </p:nvPr>
+        </p:nvSpPr>
+        <p:spPr/>
+        <p:txBody>
+          <a:bodyPr/>
+          <a:lstStyle/>
+          <a:p>
+            <a:r>
+              <a:rPr lang="en-GB" dirty="0"/>
+              <a:t>Roadmap for running the app</a:t>
+            </a:r>
+          </a:p>
+        </p:txBody>
+      </p:sp>
+      <p:sp>
+        <p:nvSpPr>
+          <p:cNvPr id="3" name="Content Placeholder 2">
+            <a:extLst>
+              <a:ext uri="{FF2B5EF4-FFF2-40B4-BE49-F238E27FC236}">
+                <a16:creationId xmlns:a16="http://schemas.microsoft.com/office/drawing/2014/main" id="{A095A4D4-31BE-17E5-1BF0-32DA190D0F6F}"/>
+              </a:ext>
+            </a:extLst>
+          </p:cNvPr>
+          <p:cNvSpPr>
+            <a:spLocks noGrp="1"/>
+          </p:cNvSpPr>
+          <p:nvPr>
+            <p:ph idx="1"/>
+          </p:nvPr>
+        </p:nvSpPr>
+        <p:spPr/>
+        <p:txBody>
+          <a:bodyPr/>
+          <a:lstStyle/>
+          <a:p>
+            <a:r>
+              <a:rPr lang="en-GB" dirty="0"/>
+              <a:t>Development</a:t>
+            </a:r>
+          </a:p>
+          <a:p>
+            <a:pPr lvl="1"/>
+            <a:r>
+              <a:rPr lang="en-GB" dirty="0"/>
+              <a:t>Docker Desktop (on Windows)</a:t>
+            </a:r>
+          </a:p>
+          <a:p>
+            <a:pPr lvl="1"/>
+            <a:r>
+              <a:rPr lang="en-GB" dirty="0"/>
+              <a:t>Azurite (Blob)</a:t>
+            </a:r>
+          </a:p>
+          <a:p>
+            <a:r>
+              <a:rPr lang="en-GB" dirty="0"/>
+              <a:t>Stage/Live</a:t>
+            </a:r>
+          </a:p>
+          <a:p>
+            <a:pPr lvl="1"/>
+            <a:r>
+              <a:rPr lang="en-GB" dirty="0"/>
+              <a:t>Azure</a:t>
+            </a:r>
+          </a:p>
+          <a:p>
+            <a:pPr lvl="1"/>
+            <a:r>
+              <a:rPr lang="en-GB" dirty="0"/>
+              <a:t>Cross the bridge</a:t>
+            </a:r>
+          </a:p>
+          <a:p>
+            <a:pPr lvl="1"/>
+            <a:endParaRPr lang="en-GB" dirty="0"/>
+          </a:p>
+        </p:txBody>
+      </p:sp>
+    </p:spTree>
+    <p:extLst>
+      <p:ext uri="{BB962C8B-B14F-4D97-AF65-F5344CB8AC3E}">
+        <p14:creationId xmlns:p14="http://schemas.microsoft.com/office/powerpoint/2010/main" val="641281012"/>
+      </p:ext>
+    </p:extLst>
+  </p:cSld>
+  <p:clrMapOvr>
+    <a:masterClrMapping/>
+  </p:clrMapOvr>
+</p:sld>
+</file>
+
+<file path=ppt/slides/slide9.xml><?xml version="1.0" encoding="utf-8"?>
+<p:sld xmlns:a="http://schemas.openxmlformats.org/drawingml/2006/main" xmlns:r="http://schemas.openxmlformats.org/officeDocument/2006/relationships" xmlns:p="http://schemas.openxmlformats.org/presentationml/2006/main">
+  <p:cSld>
+    <p:spTree>
+      <p:nvGrpSpPr>
+        <p:cNvPr id="1" name=""/>
+        <p:cNvGrpSpPr/>
+        <p:nvPr/>
+      </p:nvGrpSpPr>
+      <p:grpSpPr>
+        <a:xfrm>
+          <a:off x="0" y="0"/>
+          <a:ext cx="0" cy="0"/>
+          <a:chOff x="0" y="0"/>
+          <a:chExt cx="0" cy="0"/>
+        </a:xfrm>
+      </p:grpSpPr>
+      <p:sp>
+        <p:nvSpPr>
+          <p:cNvPr id="2" name="Title 1">
+            <a:extLst>
+              <a:ext uri="{FF2B5EF4-FFF2-40B4-BE49-F238E27FC236}">
+                <a16:creationId xmlns:a16="http://schemas.microsoft.com/office/drawing/2014/main" id="{7B8D33B3-52EB-2407-8D20-94B516389D2A}"/>
+              </a:ext>
+            </a:extLst>
+          </p:cNvPr>
+          <p:cNvSpPr>
+            <a:spLocks noGrp="1"/>
+          </p:cNvSpPr>
+          <p:nvPr>
+            <p:ph type="title"/>
+          </p:nvPr>
+        </p:nvSpPr>
+        <p:spPr/>
+        <p:txBody>
+          <a:bodyPr/>
+          <a:lstStyle/>
+          <a:p>
+            <a:r>
+              <a:rPr lang="en-GB" dirty="0"/>
+              <a:t>Development Environment (dev computer)</a:t>
+            </a:r>
+          </a:p>
+        </p:txBody>
+      </p:sp>
+      <p:sp>
+        <p:nvSpPr>
+          <p:cNvPr id="3" name="Content Placeholder 2">
+            <a:extLst>
+              <a:ext uri="{FF2B5EF4-FFF2-40B4-BE49-F238E27FC236}">
+                <a16:creationId xmlns:a16="http://schemas.microsoft.com/office/drawing/2014/main" id="{0912317D-885E-B906-37FF-1DCCE7D83743}"/>
+              </a:ext>
+            </a:extLst>
+          </p:cNvPr>
+          <p:cNvSpPr>
+            <a:spLocks noGrp="1"/>
+          </p:cNvSpPr>
+          <p:nvPr>
+            <p:ph idx="1"/>
+          </p:nvPr>
+        </p:nvSpPr>
+        <p:spPr/>
+        <p:txBody>
+          <a:bodyPr/>
+          <a:lstStyle/>
+          <a:p>
+            <a:endParaRPr lang="en-GB" dirty="0"/>
+          </a:p>
+        </p:txBody>
+      </p:sp>
+    </p:spTree>
+    <p:extLst>
+      <p:ext uri="{BB962C8B-B14F-4D97-AF65-F5344CB8AC3E}">
+        <p14:creationId xmlns:p14="http://schemas.microsoft.com/office/powerpoint/2010/main" val="3220442565"/>
       </p:ext>
     </p:extLst>
   </p:cSld>

</xml_diff>